<commit_message>
Slide 3: add throughput - 15-30 TPS worldwide vs one stream's chat
Co-Authored-By: Claude Opus 5 <noreply@anthropic.com>
</commit_message>
<xml_diff>
--- a/MonadChat-pitch.pptx
+++ b/MonadChat-pitch.pptx
@@ -684,7 +684,7 @@
           <a:p>
             <a:r>
               <a:rPr lang="en-US" dirty="0"/>
-              <a:t>So why has nobody shipped this? Because on old chains it was impossible. Twelve seconds to confirm a message kills the conversation. Dollars of gas eat the word many times over. And a paid room with no spam control gets flooded by bots. Every message as a payment was an obvious idea no one could ship.</a:t>
+              <a:t>So why has nobody shipped this? Because on old chains it was impossible. Twelve seconds to confirm a message kills the conversation. Fifteen to thirty TPS for the whole planet — one busy stream’s chat outruns the entire chain. Dollars of gas eat the word many times over. And bots flood a paid room with no spam control. Every message as a payment was an obvious idea no one could ship.</a:t>
             </a:r>
             <a:endParaRPr lang="en-US" dirty="0"/>
           </a:p>
@@ -2260,24 +2260,24 @@
         </p:nvSpPr>
         <p:spPr>
           <a:xfrm>
-            <a:off x="548640" y="1463040"/>
-            <a:ext cx="4480560" cy="822960"/>
-          </a:xfrm>
-          <a:prstGeom prst="rect">
-            <a:avLst/>
-          </a:prstGeom>
-          <a:noFill/>
-          <a:ln/>
-        </p:spPr>
-        <p:txBody>
-          <a:bodyPr wrap="square" lIns="0" tIns="0" rIns="0" bIns="0" rtlCol="0" anchor="ctr"/>
-          <a:lstStyle/>
-          <a:p>
-            <a:pPr indent="0" marL="0">
-              <a:buNone/>
-            </a:pPr>
-            <a:r>
-              <a:rPr lang="en-US" sz="4400" dirty="0">
+            <a:off x="548640" y="1371600"/>
+            <a:ext cx="4480560" cy="731520"/>
+          </a:xfrm>
+          <a:prstGeom prst="rect">
+            <a:avLst/>
+          </a:prstGeom>
+          <a:noFill/>
+          <a:ln/>
+        </p:spPr>
+        <p:txBody>
+          <a:bodyPr wrap="square" lIns="0" tIns="0" rIns="0" bIns="0" rtlCol="0" anchor="ctr"/>
+          <a:lstStyle/>
+          <a:p>
+            <a:pPr indent="0" marL="0">
+              <a:buNone/>
+            </a:pPr>
+            <a:r>
+              <a:rPr lang="en-US" sz="4000" dirty="0">
                 <a:solidFill>
                   <a:srgbClr val="1A1712"/>
                 </a:solidFill>
@@ -2287,7 +2287,7 @@
               </a:rPr>
               <a:t>12+ seconds</a:t>
             </a:r>
-            <a:endParaRPr lang="en-US" sz="4400" dirty="0"/>
+            <a:endParaRPr lang="en-US" sz="4000" dirty="0"/>
           </a:p>
         </p:txBody>
       </p:sp>
@@ -2299,8 +2299,8 @@
         </p:nvSpPr>
         <p:spPr>
           <a:xfrm>
-            <a:off x="5303520" y="1572768"/>
-            <a:ext cx="6309360" cy="822960"/>
+            <a:off x="5303520" y="1463040"/>
+            <a:ext cx="6309360" cy="731520"/>
           </a:xfrm>
           <a:prstGeom prst="rect">
             <a:avLst/>
@@ -2314,12 +2314,12 @@
           <a:p>
             <a:pPr indent="0" marL="0">
               <a:lnSpc>
-                <a:spcPts val="2500"/>
+                <a:spcPts val="2400"/>
               </a:lnSpc>
               <a:buNone/>
             </a:pPr>
             <a:r>
-              <a:rPr lang="en-US" sz="1900" dirty="0">
+              <a:rPr lang="en-US" sz="1800" dirty="0">
                 <a:solidFill>
                   <a:srgbClr val="71685A"/>
                 </a:solidFill>
@@ -2329,7 +2329,7 @@
               </a:rPr>
               <a:t>to confirm a message — the conversation is dead on arrival</a:t>
             </a:r>
-            <a:endParaRPr lang="en-US" sz="1900" dirty="0"/>
+            <a:endParaRPr lang="en-US" sz="1800" dirty="0"/>
           </a:p>
         </p:txBody>
       </p:sp>
@@ -2341,24 +2341,24 @@
         </p:nvSpPr>
         <p:spPr>
           <a:xfrm>
-            <a:off x="548640" y="2788920"/>
-            <a:ext cx="4480560" cy="822960"/>
-          </a:xfrm>
-          <a:prstGeom prst="rect">
-            <a:avLst/>
-          </a:prstGeom>
-          <a:noFill/>
-          <a:ln/>
-        </p:spPr>
-        <p:txBody>
-          <a:bodyPr wrap="square" lIns="0" tIns="0" rIns="0" bIns="0" rtlCol="0" anchor="ctr"/>
-          <a:lstStyle/>
-          <a:p>
-            <a:pPr indent="0" marL="0">
-              <a:buNone/>
-            </a:pPr>
-            <a:r>
-              <a:rPr lang="en-US" sz="4400" dirty="0">
+            <a:off x="548640" y="2404872"/>
+            <a:ext cx="4480560" cy="731520"/>
+          </a:xfrm>
+          <a:prstGeom prst="rect">
+            <a:avLst/>
+          </a:prstGeom>
+          <a:noFill/>
+          <a:ln/>
+        </p:spPr>
+        <p:txBody>
+          <a:bodyPr wrap="square" lIns="0" tIns="0" rIns="0" bIns="0" rtlCol="0" anchor="ctr"/>
+          <a:lstStyle/>
+          <a:p>
+            <a:pPr indent="0" marL="0">
+              <a:buNone/>
+            </a:pPr>
+            <a:r>
+              <a:rPr lang="en-US" sz="4000" dirty="0">
                 <a:solidFill>
                   <a:srgbClr val="1A1712"/>
                 </a:solidFill>
@@ -2366,9 +2366,9 @@
                 <a:ea typeface="Alsina" pitchFamily="34" charset="-122"/>
                 <a:cs typeface="Alsina" pitchFamily="34" charset="-120"/>
               </a:rPr>
-              <a:t>$1–5 of gas</a:t>
-            </a:r>
-            <a:endParaRPr lang="en-US" sz="4400" dirty="0"/>
+              <a:t>15–30 TPS</a:t>
+            </a:r>
+            <a:endParaRPr lang="en-US" sz="4000" dirty="0"/>
           </a:p>
         </p:txBody>
       </p:sp>
@@ -2380,8 +2380,8 @@
         </p:nvSpPr>
         <p:spPr>
           <a:xfrm>
-            <a:off x="5303520" y="2898648"/>
-            <a:ext cx="6309360" cy="822960"/>
+            <a:off x="5303520" y="2496312"/>
+            <a:ext cx="6309360" cy="731520"/>
           </a:xfrm>
           <a:prstGeom prst="rect">
             <a:avLst/>
@@ -2395,12 +2395,12 @@
           <a:p>
             <a:pPr indent="0" marL="0">
               <a:lnSpc>
-                <a:spcPts val="2500"/>
+                <a:spcPts val="2400"/>
               </a:lnSpc>
               <a:buNone/>
             </a:pPr>
             <a:r>
-              <a:rPr lang="en-US" sz="1900" dirty="0">
+              <a:rPr lang="en-US" sz="1800" dirty="0">
                 <a:solidFill>
                   <a:srgbClr val="71685A"/>
                 </a:solidFill>
@@ -2408,9 +2408,9 @@
                 <a:ea typeface="Georgia" pitchFamily="34" charset="-122"/>
                 <a:cs typeface="Georgia" pitchFamily="34" charset="-120"/>
               </a:rPr>
-              <a:t>per message — the fee eats the word many times over</a:t>
-            </a:r>
-            <a:endParaRPr lang="en-US" sz="1900" dirty="0"/>
+              <a:t>for the whole world — one busy stream’s chat outruns the entire chain</a:t>
+            </a:r>
+            <a:endParaRPr lang="en-US" sz="1800" dirty="0"/>
           </a:p>
         </p:txBody>
       </p:sp>
@@ -2422,24 +2422,24 @@
         </p:nvSpPr>
         <p:spPr>
           <a:xfrm>
-            <a:off x="548640" y="4114800"/>
-            <a:ext cx="4480560" cy="822960"/>
-          </a:xfrm>
-          <a:prstGeom prst="rect">
-            <a:avLst/>
-          </a:prstGeom>
-          <a:noFill/>
-          <a:ln/>
-        </p:spPr>
-        <p:txBody>
-          <a:bodyPr wrap="square" lIns="0" tIns="0" rIns="0" bIns="0" rtlCol="0" anchor="ctr"/>
-          <a:lstStyle/>
-          <a:p>
-            <a:pPr indent="0" marL="0">
-              <a:buNone/>
-            </a:pPr>
-            <a:r>
-              <a:rPr lang="en-US" sz="4400" dirty="0">
+            <a:off x="548640" y="3438144"/>
+            <a:ext cx="4480560" cy="731520"/>
+          </a:xfrm>
+          <a:prstGeom prst="rect">
+            <a:avLst/>
+          </a:prstGeom>
+          <a:noFill/>
+          <a:ln/>
+        </p:spPr>
+        <p:txBody>
+          <a:bodyPr wrap="square" lIns="0" tIns="0" rIns="0" bIns="0" rtlCol="0" anchor="ctr"/>
+          <a:lstStyle/>
+          <a:p>
+            <a:pPr indent="0" marL="0">
+              <a:buNone/>
+            </a:pPr>
+            <a:r>
+              <a:rPr lang="en-US" sz="4000" dirty="0">
                 <a:solidFill>
                   <a:srgbClr val="1A1712"/>
                 </a:solidFill>
@@ -2447,9 +2447,9 @@
                 <a:ea typeface="Alsina" pitchFamily="34" charset="-122"/>
                 <a:cs typeface="Alsina" pitchFamily="34" charset="-120"/>
               </a:rPr>
-              <a:t>zero spam control</a:t>
-            </a:r>
-            <a:endParaRPr lang="en-US" sz="4400" dirty="0"/>
+              <a:t>$1–5 of gas</a:t>
+            </a:r>
+            <a:endParaRPr lang="en-US" sz="4000" dirty="0"/>
           </a:p>
         </p:txBody>
       </p:sp>
@@ -2461,8 +2461,8 @@
         </p:nvSpPr>
         <p:spPr>
           <a:xfrm>
-            <a:off x="5303520" y="4224528"/>
-            <a:ext cx="6309360" cy="822960"/>
+            <a:off x="5303520" y="3529584"/>
+            <a:ext cx="6309360" cy="731520"/>
           </a:xfrm>
           <a:prstGeom prst="rect">
             <a:avLst/>
@@ -2476,12 +2476,12 @@
           <a:p>
             <a:pPr indent="0" marL="0">
               <a:lnSpc>
-                <a:spcPts val="2500"/>
+                <a:spcPts val="2400"/>
               </a:lnSpc>
               <a:buNone/>
             </a:pPr>
             <a:r>
-              <a:rPr lang="en-US" sz="1900" dirty="0">
+              <a:rPr lang="en-US" sz="1800" dirty="0">
                 <a:solidFill>
                   <a:srgbClr val="71685A"/>
                 </a:solidFill>
@@ -2489,15 +2489,96 @@
                 <a:ea typeface="Georgia" pitchFamily="34" charset="-122"/>
                 <a:cs typeface="Georgia" pitchFamily="34" charset="-120"/>
               </a:rPr>
+              <a:t>per message — the fee eats the word many times over</a:t>
+            </a:r>
+            <a:endParaRPr lang="en-US" sz="1800" dirty="0"/>
+          </a:p>
+        </p:txBody>
+      </p:sp>
+      <p:sp>
+        <p:nvSpPr>
+          <p:cNvPr id="11" name="Text 9"/>
+          <p:cNvSpPr txBox="1"/>
+          <p:nvPr/>
+        </p:nvSpPr>
+        <p:spPr>
+          <a:xfrm>
+            <a:off x="548640" y="4471416"/>
+            <a:ext cx="4480560" cy="731520"/>
+          </a:xfrm>
+          <a:prstGeom prst="rect">
+            <a:avLst/>
+          </a:prstGeom>
+          <a:noFill/>
+          <a:ln/>
+        </p:spPr>
+        <p:txBody>
+          <a:bodyPr wrap="square" lIns="0" tIns="0" rIns="0" bIns="0" rtlCol="0" anchor="ctr"/>
+          <a:lstStyle/>
+          <a:p>
+            <a:pPr indent="0" marL="0">
+              <a:buNone/>
+            </a:pPr>
+            <a:r>
+              <a:rPr lang="en-US" sz="4000" dirty="0">
+                <a:solidFill>
+                  <a:srgbClr val="1A1712"/>
+                </a:solidFill>
+                <a:latin typeface="Alsina" pitchFamily="34" charset="0"/>
+                <a:ea typeface="Alsina" pitchFamily="34" charset="-122"/>
+                <a:cs typeface="Alsina" pitchFamily="34" charset="-120"/>
+              </a:rPr>
+              <a:t>zero spam control</a:t>
+            </a:r>
+            <a:endParaRPr lang="en-US" sz="4000" dirty="0"/>
+          </a:p>
+        </p:txBody>
+      </p:sp>
+      <p:sp>
+        <p:nvSpPr>
+          <p:cNvPr id="12" name="Text 10"/>
+          <p:cNvSpPr txBox="1"/>
+          <p:nvPr/>
+        </p:nvSpPr>
+        <p:spPr>
+          <a:xfrm>
+            <a:off x="5303520" y="4562856"/>
+            <a:ext cx="6309360" cy="731520"/>
+          </a:xfrm>
+          <a:prstGeom prst="rect">
+            <a:avLst/>
+          </a:prstGeom>
+          <a:noFill/>
+          <a:ln/>
+        </p:spPr>
+        <p:txBody>
+          <a:bodyPr wrap="square" lIns="0" tIns="0" rIns="0" bIns="0" rtlCol="0" anchor="ctr"/>
+          <a:lstStyle/>
+          <a:p>
+            <a:pPr indent="0" marL="0">
+              <a:lnSpc>
+                <a:spcPts val="2400"/>
+              </a:lnSpc>
+              <a:buNone/>
+            </a:pPr>
+            <a:r>
+              <a:rPr lang="en-US" sz="1800" dirty="0">
+                <a:solidFill>
+                  <a:srgbClr val="71685A"/>
+                </a:solidFill>
+                <a:latin typeface="Georgia" pitchFamily="34" charset="0"/>
+                <a:ea typeface="Georgia" pitchFamily="34" charset="-122"/>
+                <a:cs typeface="Georgia" pitchFamily="34" charset="-120"/>
+              </a:rPr>
               <a:t>bots flood a paid room faster than any server can ban them</a:t>
             </a:r>
-            <a:endParaRPr lang="en-US" sz="1900" dirty="0"/>
-          </a:p>
-        </p:txBody>
-      </p:sp>
-      <p:sp>
-        <p:nvSpPr>
-          <p:cNvPr id="11" name="Shape 9"/>
+            <a:endParaRPr lang="en-US" sz="1800" dirty="0"/>
+          </a:p>
+        </p:txBody>
+      </p:sp>
+      <p:sp>
+        <p:nvSpPr>
+          <p:cNvPr id="13" name="Shape 11"/>
           <p:cNvSpPr/>
           <p:nvPr/>
         </p:nvSpPr>
@@ -2520,7 +2601,7 @@
       </p:sp>
       <p:sp>
         <p:nvSpPr>
-          <p:cNvPr id="12" name="Text 10"/>
+          <p:cNvPr id="14" name="Text 12"/>
           <p:cNvSpPr txBox="1"/>
           <p:nvPr/>
         </p:nvSpPr>

</xml_diff>

<commit_message>
Deck: minimalist design - same content
Co-Authored-By: Claude Opus 5 <noreply@anthropic.com>
</commit_message>
<xml_diff>
--- a/MonadChat-pitch.pptx
+++ b/MonadChat-pitch.pptx
@@ -1411,50 +1411,30 @@
       </p:grpSpPr>
       <p:sp>
         <p:nvSpPr>
-          <p:cNvPr id="2" name="Shape 0"/>
-          <p:cNvSpPr/>
-          <p:nvPr/>
-        </p:nvSpPr>
-        <p:spPr>
-          <a:xfrm>
-            <a:off x="566928" y="673913"/>
-            <a:ext cx="261518" cy="261518"/>
-          </a:xfrm>
-          <a:prstGeom prst="rect">
-            <a:avLst/>
-          </a:prstGeom>
-          <a:solidFill>
-            <a:srgbClr val="BF3A1E"/>
-          </a:solidFill>
-          <a:ln/>
-        </p:spPr>
-      </p:sp>
-      <p:sp>
-        <p:nvSpPr>
-          <p:cNvPr id="3" name="Text 1"/>
-          <p:cNvSpPr txBox="1"/>
-          <p:nvPr/>
-        </p:nvSpPr>
-        <p:spPr>
-          <a:xfrm>
-            <a:off x="938174" y="376733"/>
-            <a:ext cx="3657600" cy="570586"/>
-          </a:xfrm>
-          <a:prstGeom prst="rect">
-            <a:avLst/>
-          </a:prstGeom>
-          <a:noFill/>
-          <a:ln/>
-        </p:spPr>
-        <p:txBody>
-          <a:bodyPr wrap="square" lIns="0" tIns="0" rIns="0" bIns="0" rtlCol="0" anchor="ctr"/>
-          <a:lstStyle/>
-          <a:p>
-            <a:pPr indent="0" marL="0">
-              <a:buNone/>
-            </a:pPr>
-            <a:r>
-              <a:rPr lang="en-US" sz="2600" dirty="0">
+          <p:cNvPr id="2" name="Text 0"/>
+          <p:cNvSpPr txBox="1"/>
+          <p:nvPr/>
+        </p:nvSpPr>
+        <p:spPr>
+          <a:xfrm>
+            <a:off x="640080" y="566928"/>
+            <a:ext cx="3657600" cy="548640"/>
+          </a:xfrm>
+          <a:prstGeom prst="rect">
+            <a:avLst/>
+          </a:prstGeom>
+          <a:noFill/>
+          <a:ln/>
+        </p:spPr>
+        <p:txBody>
+          <a:bodyPr wrap="square" lIns="0" tIns="0" rIns="0" bIns="0" rtlCol="0" anchor="ctr"/>
+          <a:lstStyle/>
+          <a:p>
+            <a:pPr indent="0" marL="0">
+              <a:buNone/>
+            </a:pPr>
+            <a:r>
+              <a:rPr lang="en-US" sz="2400" dirty="0">
                 <a:solidFill>
                   <a:srgbClr val="1A1712"/>
                 </a:solidFill>
@@ -1464,19 +1444,19 @@
               </a:rPr>
               <a:t>MonadChat</a:t>
             </a:r>
-            <a:endParaRPr lang="en-US" sz="2600" dirty="0"/>
-          </a:p>
-        </p:txBody>
-      </p:sp>
-      <p:sp>
-        <p:nvSpPr>
-          <p:cNvPr id="4" name="Text 2"/>
-          <p:cNvSpPr txBox="1"/>
-          <p:nvPr/>
-        </p:nvSpPr>
-        <p:spPr>
-          <a:xfrm>
-            <a:off x="502920" y="1371600"/>
+            <a:endParaRPr lang="en-US" sz="2400" dirty="0"/>
+          </a:p>
+        </p:txBody>
+      </p:sp>
+      <p:sp>
+        <p:nvSpPr>
+          <p:cNvPr id="3" name="Text 1"/>
+          <p:cNvSpPr txBox="1"/>
+          <p:nvPr/>
+        </p:nvSpPr>
+        <p:spPr>
+          <a:xfrm>
+            <a:off x="594360" y="1554480"/>
             <a:ext cx="11155680" cy="2743200"/>
           </a:xfrm>
           <a:prstGeom prst="rect">
@@ -1547,13 +1527,13 @@
       </p:sp>
       <p:sp>
         <p:nvSpPr>
-          <p:cNvPr id="5" name="Text 3"/>
-          <p:cNvSpPr txBox="1"/>
-          <p:nvPr/>
-        </p:nvSpPr>
-        <p:spPr>
-          <a:xfrm>
-            <a:off x="548640" y="4251960"/>
+          <p:cNvPr id="4" name="Text 2"/>
+          <p:cNvSpPr txBox="1"/>
+          <p:nvPr/>
+        </p:nvSpPr>
+        <p:spPr>
+          <a:xfrm>
+            <a:off x="640080" y="4480560"/>
             <a:ext cx="10515600" cy="548640"/>
           </a:xfrm>
           <a:prstGeom prst="rect">
@@ -1570,7 +1550,7 @@
               <a:buNone/>
             </a:pPr>
             <a:r>
-              <a:rPr lang="en-US" sz="2200" b="1" dirty="0">
+              <a:rPr lang="en-US" sz="2100" b="1" dirty="0">
                 <a:solidFill>
                   <a:srgbClr val="1A1712"/>
                 </a:solidFill>
@@ -1584,7 +1564,7 @@
               <a:buNone/>
             </a:pPr>
             <a:r>
-              <a:rPr lang="en-US" sz="2200" dirty="0">
+              <a:rPr lang="en-US" sz="2100" dirty="0">
                 <a:solidFill>
                   <a:srgbClr val="1A1712"/>
                 </a:solidFill>
@@ -1594,42 +1574,19 @@
               </a:rPr>
               <a:t>Streamers keep 100%, paid the same second.</a:t>
             </a:r>
-            <a:endParaRPr lang="en-US" sz="2200" dirty="0"/>
-          </a:p>
-        </p:txBody>
-      </p:sp>
-      <p:sp>
-        <p:nvSpPr>
-          <p:cNvPr id="6" name="Shape 4"/>
-          <p:cNvSpPr/>
-          <p:nvPr/>
-        </p:nvSpPr>
-        <p:spPr>
-          <a:xfrm>
-            <a:off x="548640" y="5806440"/>
-            <a:ext cx="11091672" cy="0"/>
-          </a:xfrm>
-          <a:prstGeom prst="line">
-            <a:avLst/>
-          </a:prstGeom>
-          <a:noFill/>
-          <a:ln w="17780">
-            <a:solidFill>
-              <a:srgbClr val="1A1712"/>
-            </a:solidFill>
-            <a:prstDash val="solid"/>
-          </a:ln>
-        </p:spPr>
-      </p:sp>
-      <p:sp>
-        <p:nvSpPr>
-          <p:cNvPr id="7" name="Text 5"/>
-          <p:cNvSpPr txBox="1"/>
-          <p:nvPr/>
-        </p:nvSpPr>
-        <p:spPr>
-          <a:xfrm>
-            <a:off x="548640" y="5943600"/>
+            <a:endParaRPr lang="en-US" sz="2100" dirty="0"/>
+          </a:p>
+        </p:txBody>
+      </p:sp>
+      <p:sp>
+        <p:nvSpPr>
+          <p:cNvPr id="5" name="Text 3"/>
+          <p:cNvSpPr txBox="1"/>
+          <p:nvPr/>
+        </p:nvSpPr>
+        <p:spPr>
+          <a:xfrm>
+            <a:off x="640080" y="6035040"/>
             <a:ext cx="5486400" cy="365760"/>
           </a:xfrm>
           <a:prstGeom prst="rect">
@@ -1646,9 +1603,9 @@
               <a:buNone/>
             </a:pPr>
             <a:r>
-              <a:rPr lang="en-US" sz="1300" spc="300" kern="0" dirty="0">
-                <a:solidFill>
-                  <a:srgbClr val="71685A"/>
+              <a:rPr lang="en-US" sz="1200" spc="300" kern="0" dirty="0">
+                <a:solidFill>
+                  <a:srgbClr val="8A8274"/>
                 </a:solidFill>
                 <a:latin typeface="Courier New" pitchFamily="34" charset="0"/>
                 <a:ea typeface="Courier New" pitchFamily="34" charset="-122"/>
@@ -1656,19 +1613,19 @@
               </a:rPr>
               <a:t>MONAD BLITZ · AMSTERDAM · 2026</a:t>
             </a:r>
-            <a:endParaRPr lang="en-US" sz="1300" dirty="0"/>
-          </a:p>
-        </p:txBody>
-      </p:sp>
-      <p:sp>
-        <p:nvSpPr>
-          <p:cNvPr id="8" name="Text 6"/>
-          <p:cNvSpPr txBox="1"/>
-          <p:nvPr/>
-        </p:nvSpPr>
-        <p:spPr>
-          <a:xfrm>
-            <a:off x="6583680" y="5943600"/>
+            <a:endParaRPr lang="en-US" sz="1200" dirty="0"/>
+          </a:p>
+        </p:txBody>
+      </p:sp>
+      <p:sp>
+        <p:nvSpPr>
+          <p:cNvPr id="6" name="Text 4"/>
+          <p:cNvSpPr txBox="1"/>
+          <p:nvPr/>
+        </p:nvSpPr>
+        <p:spPr>
+          <a:xfrm>
+            <a:off x="6492240" y="6035040"/>
             <a:ext cx="5029200" cy="365760"/>
           </a:xfrm>
           <a:prstGeom prst="rect">
@@ -1685,7 +1642,7 @@
               <a:buNone/>
             </a:pPr>
             <a:r>
-              <a:rPr lang="en-US" sz="1500" b="1" dirty="0">
+              <a:rPr lang="en-US" sz="1400" b="1" dirty="0">
                 <a:solidFill>
                   <a:srgbClr val="BF3A1E"/>
                 </a:solidFill>
@@ -1695,7 +1652,7 @@
               </a:rPr>
               <a:t>monadchat-rvfc1.vercel.app</a:t>
             </a:r>
-            <a:endParaRPr lang="en-US" sz="1500" dirty="0"/>
+            <a:endParaRPr lang="en-US" sz="1400" dirty="0"/>
           </a:p>
         </p:txBody>
       </p:sp>
@@ -1739,26 +1696,26 @@
         </p:nvSpPr>
         <p:spPr>
           <a:xfrm>
-            <a:off x="548640" y="411480"/>
-            <a:ext cx="10424160" cy="502920"/>
-          </a:xfrm>
-          <a:prstGeom prst="rect">
-            <a:avLst/>
-          </a:prstGeom>
-          <a:noFill/>
-          <a:ln/>
-        </p:spPr>
-        <p:txBody>
-          <a:bodyPr wrap="square" lIns="0" tIns="0" rIns="0" bIns="0" rtlCol="0" anchor="ctr"/>
-          <a:lstStyle/>
-          <a:p>
-            <a:pPr indent="0" marL="0">
-              <a:buNone/>
-            </a:pPr>
-            <a:r>
-              <a:rPr lang="en-US" sz="1600" b="1" spc="300" kern="0" dirty="0">
-                <a:solidFill>
-                  <a:srgbClr val="1A1712"/>
+            <a:off x="640080" y="457200"/>
+            <a:ext cx="10058400" cy="365760"/>
+          </a:xfrm>
+          <a:prstGeom prst="rect">
+            <a:avLst/>
+          </a:prstGeom>
+          <a:noFill/>
+          <a:ln/>
+        </p:spPr>
+        <p:txBody>
+          <a:bodyPr wrap="square" lIns="0" tIns="0" rIns="0" bIns="0" rtlCol="0" anchor="ctr"/>
+          <a:lstStyle/>
+          <a:p>
+            <a:pPr indent="0" marL="0">
+              <a:buNone/>
+            </a:pPr>
+            <a:r>
+              <a:rPr lang="en-US" sz="1200" b="1" spc="300" kern="0" dirty="0">
+                <a:solidFill>
+                  <a:srgbClr val="8A8274"/>
                 </a:solidFill>
                 <a:latin typeface="Courier New" pitchFamily="34" charset="0"/>
                 <a:ea typeface="Courier New" pitchFamily="34" charset="-122"/>
@@ -1766,7 +1723,7 @@
               </a:rPr>
               <a:t>STREAMERS WANT TO GET PAID FOR CHAT</a:t>
             </a:r>
-            <a:endParaRPr lang="en-US" sz="1600" dirty="0"/>
+            <a:endParaRPr lang="en-US" sz="1200" dirty="0"/>
           </a:p>
         </p:txBody>
       </p:sp>
@@ -1778,8 +1735,8 @@
         </p:nvSpPr>
         <p:spPr>
           <a:xfrm>
-            <a:off x="11137392" y="411480"/>
-            <a:ext cx="502920" cy="502920"/>
+            <a:off x="11045952" y="457200"/>
+            <a:ext cx="502920" cy="365760"/>
           </a:xfrm>
           <a:prstGeom prst="rect">
             <a:avLst/>
@@ -1795,9 +1752,9 @@
               <a:buNone/>
             </a:pPr>
             <a:r>
-              <a:rPr lang="en-US" sz="1600" dirty="0">
-                <a:solidFill>
-                  <a:srgbClr val="71685A"/>
+              <a:rPr lang="en-US" sz="1200" dirty="0">
+                <a:solidFill>
+                  <a:srgbClr val="8A8274"/>
                 </a:solidFill>
                 <a:latin typeface="Courier New" pitchFamily="34" charset="0"/>
                 <a:ea typeface="Courier New" pitchFamily="34" charset="-122"/>
@@ -1805,43 +1762,20 @@
               </a:rPr>
               <a:t>02</a:t>
             </a:r>
-            <a:endParaRPr lang="en-US" sz="1600" dirty="0"/>
-          </a:p>
-        </p:txBody>
-      </p:sp>
-      <p:sp>
-        <p:nvSpPr>
-          <p:cNvPr id="4" name="Shape 2"/>
-          <p:cNvSpPr/>
-          <p:nvPr/>
-        </p:nvSpPr>
-        <p:spPr>
-          <a:xfrm>
-            <a:off x="548640" y="960120"/>
-            <a:ext cx="11091672" cy="0"/>
-          </a:xfrm>
-          <a:prstGeom prst="line">
-            <a:avLst/>
-          </a:prstGeom>
-          <a:noFill/>
-          <a:ln w="15240">
-            <a:solidFill>
-              <a:srgbClr val="1A1712"/>
-            </a:solidFill>
-            <a:prstDash val="solid"/>
-          </a:ln>
-        </p:spPr>
-      </p:sp>
-      <p:sp>
-        <p:nvSpPr>
-          <p:cNvPr id="5" name="Text 3"/>
-          <p:cNvSpPr txBox="1"/>
-          <p:nvPr/>
-        </p:nvSpPr>
-        <p:spPr>
-          <a:xfrm>
-            <a:off x="548640" y="1371600"/>
-            <a:ext cx="11064240" cy="1188720"/>
+            <a:endParaRPr lang="en-US" sz="1200" dirty="0"/>
+          </a:p>
+        </p:txBody>
+      </p:sp>
+      <p:sp>
+        <p:nvSpPr>
+          <p:cNvPr id="4" name="Text 2"/>
+          <p:cNvSpPr txBox="1"/>
+          <p:nvPr/>
+        </p:nvSpPr>
+        <p:spPr>
+          <a:xfrm>
+            <a:off x="640080" y="1280160"/>
+            <a:ext cx="10972800" cy="1188720"/>
           </a:xfrm>
           <a:prstGeom prst="rect">
             <a:avLst/>
@@ -1855,12 +1789,12 @@
           <a:p>
             <a:pPr indent="0" marL="0">
               <a:lnSpc>
-                <a:spcPts val="3600"/>
+                <a:spcPts val="3500"/>
               </a:lnSpc>
               <a:buNone/>
             </a:pPr>
             <a:r>
-              <a:rPr lang="en-US" sz="2800" dirty="0">
+              <a:rPr lang="en-US" sz="2700" dirty="0">
                 <a:solidFill>
                   <a:srgbClr val="1A1712"/>
                 </a:solidFill>
@@ -1870,17 +1804,17 @@
               </a:rPr>
               <a:t>Chat is the most engaged part of every stream —</a:t>
             </a:r>
-            <a:endParaRPr lang="en-US" sz="2800" dirty="0"/>
+            <a:endParaRPr lang="en-US" sz="2700" dirty="0"/>
           </a:p>
           <a:p>
             <a:pPr indent="0" marL="0">
               <a:lnSpc>
-                <a:spcPts val="3600"/>
+                <a:spcPts val="3500"/>
               </a:lnSpc>
               <a:buNone/>
             </a:pPr>
             <a:r>
-              <a:rPr lang="en-US" sz="2800" dirty="0">
+              <a:rPr lang="en-US" sz="2700" dirty="0">
                 <a:solidFill>
                   <a:srgbClr val="1A1712"/>
                 </a:solidFill>
@@ -1890,20 +1824,20 @@
               </a:rPr>
               <a:t>and it pays the streamer nothing.</a:t>
             </a:r>
-            <a:endParaRPr lang="en-US" sz="2800" dirty="0"/>
-          </a:p>
-        </p:txBody>
-      </p:sp>
-      <p:sp>
-        <p:nvSpPr>
-          <p:cNvPr id="6" name="Text 4"/>
-          <p:cNvSpPr txBox="1"/>
-          <p:nvPr/>
-        </p:nvSpPr>
-        <p:spPr>
-          <a:xfrm>
-            <a:off x="548640" y="2788920"/>
-            <a:ext cx="11064240" cy="914400"/>
+            <a:endParaRPr lang="en-US" sz="2700" dirty="0"/>
+          </a:p>
+        </p:txBody>
+      </p:sp>
+      <p:sp>
+        <p:nvSpPr>
+          <p:cNvPr id="5" name="Text 3"/>
+          <p:cNvSpPr txBox="1"/>
+          <p:nvPr/>
+        </p:nvSpPr>
+        <p:spPr>
+          <a:xfrm>
+            <a:off x="640080" y="2743200"/>
+            <a:ext cx="10972800" cy="914400"/>
           </a:xfrm>
           <a:prstGeom prst="rect">
             <a:avLst/>
@@ -1917,14 +1851,14 @@
           <a:p>
             <a:pPr indent="0" marL="0">
               <a:lnSpc>
-                <a:spcPts val="2700"/>
+                <a:spcPts val="2600"/>
               </a:lnSpc>
               <a:buNone/>
             </a:pPr>
             <a:r>
-              <a:rPr lang="en-US" sz="1900" dirty="0">
-                <a:solidFill>
-                  <a:srgbClr val="1A1712"/>
+              <a:rPr lang="en-US" sz="1800" dirty="0">
+                <a:solidFill>
+                  <a:srgbClr val="8A8274"/>
                 </a:solidFill>
                 <a:latin typeface="Georgia" pitchFamily="34" charset="0"/>
                 <a:ea typeface="Georgia" pitchFamily="34" charset="-122"/>
@@ -1932,19 +1866,19 @@
               </a:rPr>
               <a:t>Fans already pay to be seen — Superchat is a billion-dollar behavior.</a:t>
             </a:r>
-            <a:endParaRPr lang="en-US" sz="1900" dirty="0"/>
+            <a:endParaRPr lang="en-US" sz="1800" dirty="0"/>
           </a:p>
           <a:p>
             <a:pPr indent="0" marL="0">
               <a:lnSpc>
-                <a:spcPts val="2700"/>
+                <a:spcPts val="2600"/>
               </a:lnSpc>
               <a:buNone/>
             </a:pPr>
             <a:r>
-              <a:rPr lang="en-US" sz="1900" dirty="0">
-                <a:solidFill>
-                  <a:srgbClr val="1A1712"/>
+              <a:rPr lang="en-US" sz="1800" dirty="0">
+                <a:solidFill>
+                  <a:srgbClr val="8A8274"/>
                 </a:solidFill>
                 <a:latin typeface="Georgia" pitchFamily="34" charset="0"/>
                 <a:ea typeface="Georgia" pitchFamily="34" charset="-122"/>
@@ -1952,19 +1886,19 @@
               </a:rPr>
               <a:t>But the platform stands between every fan and every streamer:</a:t>
             </a:r>
-            <a:endParaRPr lang="en-US" sz="1900" dirty="0"/>
-          </a:p>
-        </p:txBody>
-      </p:sp>
-      <p:sp>
-        <p:nvSpPr>
-          <p:cNvPr id="7" name="Text 5"/>
-          <p:cNvSpPr txBox="1"/>
-          <p:nvPr/>
-        </p:nvSpPr>
-        <p:spPr>
-          <a:xfrm>
-            <a:off x="502920" y="3794760"/>
+            <a:endParaRPr lang="en-US" sz="1800" dirty="0"/>
+          </a:p>
+        </p:txBody>
+      </p:sp>
+      <p:sp>
+        <p:nvSpPr>
+          <p:cNvPr id="6" name="Text 4"/>
+          <p:cNvSpPr txBox="1"/>
+          <p:nvPr/>
+        </p:nvSpPr>
+        <p:spPr>
+          <a:xfrm>
+            <a:off x="594360" y="3749040"/>
             <a:ext cx="4937760" cy="1371600"/>
           </a:xfrm>
           <a:prstGeom prst="rect">
@@ -1983,7 +1917,7 @@
             <a:r>
               <a:rPr lang="en-US" sz="9200" dirty="0">
                 <a:solidFill>
-                  <a:srgbClr val="BF3A1E"/>
+                  <a:srgbClr val="1A1712"/>
                 </a:solidFill>
                 <a:latin typeface="Alsina" pitchFamily="34" charset="0"/>
                 <a:ea typeface="Alsina" pitchFamily="34" charset="-122"/>
@@ -1997,14 +1931,14 @@
       </p:sp>
       <p:sp>
         <p:nvSpPr>
-          <p:cNvPr id="8" name="Text 6"/>
-          <p:cNvSpPr txBox="1"/>
-          <p:nvPr/>
-        </p:nvSpPr>
-        <p:spPr>
-          <a:xfrm>
-            <a:off x="5577840" y="4160520"/>
-            <a:ext cx="6035040" cy="822960"/>
+          <p:cNvPr id="7" name="Text 5"/>
+          <p:cNvSpPr txBox="1"/>
+          <p:nvPr/>
+        </p:nvSpPr>
+        <p:spPr>
+          <a:xfrm>
+            <a:off x="5669280" y="4114800"/>
+            <a:ext cx="5852160" cy="822960"/>
           </a:xfrm>
           <a:prstGeom prst="rect">
             <a:avLst/>
@@ -2018,12 +1952,12 @@
           <a:p>
             <a:pPr indent="0" marL="0">
               <a:lnSpc>
-                <a:spcPts val="2700"/>
+                <a:spcPts val="2600"/>
               </a:lnSpc>
               <a:buNone/>
             </a:pPr>
             <a:r>
-              <a:rPr lang="en-US" sz="2000" dirty="0">
+              <a:rPr lang="en-US" sz="1900" dirty="0">
                 <a:solidFill>
                   <a:srgbClr val="1A1712"/>
                 </a:solidFill>
@@ -2033,17 +1967,17 @@
               </a:rPr>
               <a:t>platform take</a:t>
             </a:r>
-            <a:endParaRPr lang="en-US" sz="2000" dirty="0"/>
+            <a:endParaRPr lang="en-US" sz="1900" dirty="0"/>
           </a:p>
           <a:p>
             <a:pPr indent="0" marL="0">
               <a:lnSpc>
-                <a:spcPts val="2700"/>
+                <a:spcPts val="2600"/>
               </a:lnSpc>
               <a:buNone/>
             </a:pPr>
             <a:r>
-              <a:rPr lang="en-US" sz="2000" dirty="0">
+              <a:rPr lang="en-US" sz="1900" dirty="0">
                 <a:solidFill>
                   <a:srgbClr val="1A1712"/>
                 </a:solidFill>
@@ -2053,61 +1987,38 @@
               </a:rPr>
               <a:t>weeks to payout · their rules</a:t>
             </a:r>
-            <a:endParaRPr lang="en-US" sz="2000" dirty="0"/>
-          </a:p>
-        </p:txBody>
-      </p:sp>
-      <p:sp>
-        <p:nvSpPr>
-          <p:cNvPr id="9" name="Shape 7"/>
-          <p:cNvSpPr/>
-          <p:nvPr/>
-        </p:nvSpPr>
-        <p:spPr>
-          <a:xfrm>
-            <a:off x="548640" y="5806440"/>
-            <a:ext cx="11091672" cy="0"/>
-          </a:xfrm>
-          <a:prstGeom prst="line">
-            <a:avLst/>
-          </a:prstGeom>
-          <a:noFill/>
-          <a:ln w="12700">
-            <a:solidFill>
-              <a:srgbClr val="D8CDB8"/>
-            </a:solidFill>
-            <a:prstDash val="solid"/>
-          </a:ln>
-        </p:spPr>
-      </p:sp>
-      <p:sp>
-        <p:nvSpPr>
-          <p:cNvPr id="10" name="Text 8"/>
-          <p:cNvSpPr txBox="1"/>
-          <p:nvPr/>
-        </p:nvSpPr>
-        <p:spPr>
-          <a:xfrm>
-            <a:off x="548640" y="5943600"/>
-            <a:ext cx="11064240" cy="457200"/>
-          </a:xfrm>
-          <a:prstGeom prst="rect">
-            <a:avLst/>
-          </a:prstGeom>
-          <a:noFill/>
-          <a:ln/>
-        </p:spPr>
-        <p:txBody>
-          <a:bodyPr wrap="square" lIns="0" tIns="0" rIns="0" bIns="0" rtlCol="0" anchor="ctr"/>
-          <a:lstStyle/>
-          <a:p>
-            <a:pPr indent="0" marL="0">
-              <a:buNone/>
-            </a:pPr>
-            <a:r>
-              <a:rPr lang="en-US" sz="1800" i="1" dirty="0">
-                <a:solidFill>
-                  <a:srgbClr val="71685A"/>
+            <a:endParaRPr lang="en-US" sz="1900" dirty="0"/>
+          </a:p>
+        </p:txBody>
+      </p:sp>
+      <p:sp>
+        <p:nvSpPr>
+          <p:cNvPr id="8" name="Text 6"/>
+          <p:cNvSpPr txBox="1"/>
+          <p:nvPr/>
+        </p:nvSpPr>
+        <p:spPr>
+          <a:xfrm>
+            <a:off x="640080" y="5897880"/>
+            <a:ext cx="10972800" cy="457200"/>
+          </a:xfrm>
+          <a:prstGeom prst="rect">
+            <a:avLst/>
+          </a:prstGeom>
+          <a:noFill/>
+          <a:ln/>
+        </p:spPr>
+        <p:txBody>
+          <a:bodyPr wrap="square" lIns="0" tIns="0" rIns="0" bIns="0" rtlCol="0" anchor="ctr"/>
+          <a:lstStyle/>
+          <a:p>
+            <a:pPr indent="0" marL="0">
+              <a:buNone/>
+            </a:pPr>
+            <a:r>
+              <a:rPr lang="en-US" sz="1700" i="1" dirty="0">
+                <a:solidFill>
+                  <a:srgbClr val="8A8274"/>
                 </a:solidFill>
                 <a:latin typeface="Georgia" pitchFamily="34" charset="0"/>
                 <a:ea typeface="Georgia" pitchFamily="34" charset="-122"/>
@@ -2115,7 +2026,7 @@
               </a:rPr>
               <a:t>The demand is proven. The rails are broken.</a:t>
             </a:r>
-            <a:endParaRPr lang="en-US" sz="1800" dirty="0"/>
+            <a:endParaRPr lang="en-US" sz="1700" dirty="0"/>
           </a:p>
         </p:txBody>
       </p:sp>
@@ -2159,26 +2070,26 @@
         </p:nvSpPr>
         <p:spPr>
           <a:xfrm>
-            <a:off x="548640" y="411480"/>
-            <a:ext cx="10424160" cy="502920"/>
-          </a:xfrm>
-          <a:prstGeom prst="rect">
-            <a:avLst/>
-          </a:prstGeom>
-          <a:noFill/>
-          <a:ln/>
-        </p:spPr>
-        <p:txBody>
-          <a:bodyPr wrap="square" lIns="0" tIns="0" rIns="0" bIns="0" rtlCol="0" anchor="ctr"/>
-          <a:lstStyle/>
-          <a:p>
-            <a:pPr indent="0" marL="0">
-              <a:buNone/>
-            </a:pPr>
-            <a:r>
-              <a:rPr lang="en-US" sz="1600" b="1" spc="300" kern="0" dirty="0">
-                <a:solidFill>
-                  <a:srgbClr val="1A1712"/>
+            <a:off x="640080" y="457200"/>
+            <a:ext cx="10058400" cy="365760"/>
+          </a:xfrm>
+          <a:prstGeom prst="rect">
+            <a:avLst/>
+          </a:prstGeom>
+          <a:noFill/>
+          <a:ln/>
+        </p:spPr>
+        <p:txBody>
+          <a:bodyPr wrap="square" lIns="0" tIns="0" rIns="0" bIns="0" rtlCol="0" anchor="ctr"/>
+          <a:lstStyle/>
+          <a:p>
+            <a:pPr indent="0" marL="0">
+              <a:buNone/>
+            </a:pPr>
+            <a:r>
+              <a:rPr lang="en-US" sz="1200" b="1" spc="300" kern="0" dirty="0">
+                <a:solidFill>
+                  <a:srgbClr val="8A8274"/>
                 </a:solidFill>
                 <a:latin typeface="Courier New" pitchFamily="34" charset="0"/>
                 <a:ea typeface="Courier New" pitchFamily="34" charset="-122"/>
@@ -2186,7 +2097,7 @@
               </a:rPr>
               <a:t>ON OLD BLOCKCHAINS THIS WAS IMPOSSIBLE</a:t>
             </a:r>
-            <a:endParaRPr lang="en-US" sz="1600" dirty="0"/>
+            <a:endParaRPr lang="en-US" sz="1200" dirty="0"/>
           </a:p>
         </p:txBody>
       </p:sp>
@@ -2198,8 +2109,8 @@
         </p:nvSpPr>
         <p:spPr>
           <a:xfrm>
-            <a:off x="11137392" y="411480"/>
-            <a:ext cx="502920" cy="502920"/>
+            <a:off x="11045952" y="457200"/>
+            <a:ext cx="502920" cy="365760"/>
           </a:xfrm>
           <a:prstGeom prst="rect">
             <a:avLst/>
@@ -2215,9 +2126,9 @@
               <a:buNone/>
             </a:pPr>
             <a:r>
-              <a:rPr lang="en-US" sz="1600" dirty="0">
-                <a:solidFill>
-                  <a:srgbClr val="71685A"/>
+              <a:rPr lang="en-US" sz="1200" dirty="0">
+                <a:solidFill>
+                  <a:srgbClr val="8A8274"/>
                 </a:solidFill>
                 <a:latin typeface="Courier New" pitchFamily="34" charset="0"/>
                 <a:ea typeface="Courier New" pitchFamily="34" charset="-122"/>
@@ -2225,42 +2136,19 @@
               </a:rPr>
               <a:t>03</a:t>
             </a:r>
-            <a:endParaRPr lang="en-US" sz="1600" dirty="0"/>
-          </a:p>
-        </p:txBody>
-      </p:sp>
-      <p:sp>
-        <p:nvSpPr>
-          <p:cNvPr id="4" name="Shape 2"/>
-          <p:cNvSpPr/>
-          <p:nvPr/>
-        </p:nvSpPr>
-        <p:spPr>
-          <a:xfrm>
-            <a:off x="548640" y="960120"/>
-            <a:ext cx="11091672" cy="0"/>
-          </a:xfrm>
-          <a:prstGeom prst="line">
-            <a:avLst/>
-          </a:prstGeom>
-          <a:noFill/>
-          <a:ln w="15240">
-            <a:solidFill>
-              <a:srgbClr val="1A1712"/>
-            </a:solidFill>
-            <a:prstDash val="solid"/>
-          </a:ln>
-        </p:spPr>
-      </p:sp>
-      <p:sp>
-        <p:nvSpPr>
-          <p:cNvPr id="5" name="Text 3"/>
-          <p:cNvSpPr txBox="1"/>
-          <p:nvPr/>
-        </p:nvSpPr>
-        <p:spPr>
-          <a:xfrm>
-            <a:off x="548640" y="1371600"/>
+            <a:endParaRPr lang="en-US" sz="1200" dirty="0"/>
+          </a:p>
+        </p:txBody>
+      </p:sp>
+      <p:sp>
+        <p:nvSpPr>
+          <p:cNvPr id="4" name="Text 2"/>
+          <p:cNvSpPr txBox="1"/>
+          <p:nvPr/>
+        </p:nvSpPr>
+        <p:spPr>
+          <a:xfrm>
+            <a:off x="640080" y="1280160"/>
             <a:ext cx="4480560" cy="731520"/>
           </a:xfrm>
           <a:prstGeom prst="rect">
@@ -2293,14 +2181,14 @@
       </p:sp>
       <p:sp>
         <p:nvSpPr>
-          <p:cNvPr id="6" name="Text 4"/>
-          <p:cNvSpPr txBox="1"/>
-          <p:nvPr/>
-        </p:nvSpPr>
-        <p:spPr>
-          <a:xfrm>
-            <a:off x="5303520" y="1463040"/>
-            <a:ext cx="6309360" cy="731520"/>
+          <p:cNvPr id="5" name="Text 3"/>
+          <p:cNvSpPr txBox="1"/>
+          <p:nvPr/>
+        </p:nvSpPr>
+        <p:spPr>
+          <a:xfrm>
+            <a:off x="5394960" y="1389888"/>
+            <a:ext cx="6217920" cy="731520"/>
           </a:xfrm>
           <a:prstGeom prst="rect">
             <a:avLst/>
@@ -2314,14 +2202,14 @@
           <a:p>
             <a:pPr indent="0" marL="0">
               <a:lnSpc>
-                <a:spcPts val="2400"/>
+                <a:spcPts val="2300"/>
               </a:lnSpc>
               <a:buNone/>
             </a:pPr>
             <a:r>
-              <a:rPr lang="en-US" sz="1800" dirty="0">
-                <a:solidFill>
-                  <a:srgbClr val="71685A"/>
+              <a:rPr lang="en-US" sz="1700" dirty="0">
+                <a:solidFill>
+                  <a:srgbClr val="8A8274"/>
                 </a:solidFill>
                 <a:latin typeface="Georgia" pitchFamily="34" charset="0"/>
                 <a:ea typeface="Georgia" pitchFamily="34" charset="-122"/>
@@ -2329,19 +2217,19 @@
               </a:rPr>
               <a:t>to confirm a message — the conversation is dead on arrival</a:t>
             </a:r>
-            <a:endParaRPr lang="en-US" sz="1800" dirty="0"/>
-          </a:p>
-        </p:txBody>
-      </p:sp>
-      <p:sp>
-        <p:nvSpPr>
-          <p:cNvPr id="7" name="Text 5"/>
-          <p:cNvSpPr txBox="1"/>
-          <p:nvPr/>
-        </p:nvSpPr>
-        <p:spPr>
-          <a:xfrm>
-            <a:off x="548640" y="2404872"/>
+            <a:endParaRPr lang="en-US" sz="1700" dirty="0"/>
+          </a:p>
+        </p:txBody>
+      </p:sp>
+      <p:sp>
+        <p:nvSpPr>
+          <p:cNvPr id="6" name="Text 4"/>
+          <p:cNvSpPr txBox="1"/>
+          <p:nvPr/>
+        </p:nvSpPr>
+        <p:spPr>
+          <a:xfrm>
+            <a:off x="640080" y="2331720"/>
             <a:ext cx="4480560" cy="731520"/>
           </a:xfrm>
           <a:prstGeom prst="rect">
@@ -2374,14 +2262,14 @@
       </p:sp>
       <p:sp>
         <p:nvSpPr>
-          <p:cNvPr id="8" name="Text 6"/>
-          <p:cNvSpPr txBox="1"/>
-          <p:nvPr/>
-        </p:nvSpPr>
-        <p:spPr>
-          <a:xfrm>
-            <a:off x="5303520" y="2496312"/>
-            <a:ext cx="6309360" cy="731520"/>
+          <p:cNvPr id="7" name="Text 5"/>
+          <p:cNvSpPr txBox="1"/>
+          <p:nvPr/>
+        </p:nvSpPr>
+        <p:spPr>
+          <a:xfrm>
+            <a:off x="5394960" y="2441448"/>
+            <a:ext cx="6217920" cy="731520"/>
           </a:xfrm>
           <a:prstGeom prst="rect">
             <a:avLst/>
@@ -2395,14 +2283,14 @@
           <a:p>
             <a:pPr indent="0" marL="0">
               <a:lnSpc>
-                <a:spcPts val="2400"/>
+                <a:spcPts val="2300"/>
               </a:lnSpc>
               <a:buNone/>
             </a:pPr>
             <a:r>
-              <a:rPr lang="en-US" sz="1800" dirty="0">
-                <a:solidFill>
-                  <a:srgbClr val="71685A"/>
+              <a:rPr lang="en-US" sz="1700" dirty="0">
+                <a:solidFill>
+                  <a:srgbClr val="8A8274"/>
                 </a:solidFill>
                 <a:latin typeface="Georgia" pitchFamily="34" charset="0"/>
                 <a:ea typeface="Georgia" pitchFamily="34" charset="-122"/>
@@ -2410,19 +2298,19 @@
               </a:rPr>
               <a:t>for the whole world — one busy stream’s chat outruns the entire chain</a:t>
             </a:r>
-            <a:endParaRPr lang="en-US" sz="1800" dirty="0"/>
-          </a:p>
-        </p:txBody>
-      </p:sp>
-      <p:sp>
-        <p:nvSpPr>
-          <p:cNvPr id="9" name="Text 7"/>
-          <p:cNvSpPr txBox="1"/>
-          <p:nvPr/>
-        </p:nvSpPr>
-        <p:spPr>
-          <a:xfrm>
-            <a:off x="548640" y="3438144"/>
+            <a:endParaRPr lang="en-US" sz="1700" dirty="0"/>
+          </a:p>
+        </p:txBody>
+      </p:sp>
+      <p:sp>
+        <p:nvSpPr>
+          <p:cNvPr id="8" name="Text 6"/>
+          <p:cNvSpPr txBox="1"/>
+          <p:nvPr/>
+        </p:nvSpPr>
+        <p:spPr>
+          <a:xfrm>
+            <a:off x="640080" y="3383280"/>
             <a:ext cx="4480560" cy="731520"/>
           </a:xfrm>
           <a:prstGeom prst="rect">
@@ -2455,14 +2343,14 @@
       </p:sp>
       <p:sp>
         <p:nvSpPr>
-          <p:cNvPr id="10" name="Text 8"/>
-          <p:cNvSpPr txBox="1"/>
-          <p:nvPr/>
-        </p:nvSpPr>
-        <p:spPr>
-          <a:xfrm>
-            <a:off x="5303520" y="3529584"/>
-            <a:ext cx="6309360" cy="731520"/>
+          <p:cNvPr id="9" name="Text 7"/>
+          <p:cNvSpPr txBox="1"/>
+          <p:nvPr/>
+        </p:nvSpPr>
+        <p:spPr>
+          <a:xfrm>
+            <a:off x="5394960" y="3493008"/>
+            <a:ext cx="6217920" cy="731520"/>
           </a:xfrm>
           <a:prstGeom prst="rect">
             <a:avLst/>
@@ -2476,14 +2364,14 @@
           <a:p>
             <a:pPr indent="0" marL="0">
               <a:lnSpc>
-                <a:spcPts val="2400"/>
+                <a:spcPts val="2300"/>
               </a:lnSpc>
               <a:buNone/>
             </a:pPr>
             <a:r>
-              <a:rPr lang="en-US" sz="1800" dirty="0">
-                <a:solidFill>
-                  <a:srgbClr val="71685A"/>
+              <a:rPr lang="en-US" sz="1700" dirty="0">
+                <a:solidFill>
+                  <a:srgbClr val="8A8274"/>
                 </a:solidFill>
                 <a:latin typeface="Georgia" pitchFamily="34" charset="0"/>
                 <a:ea typeface="Georgia" pitchFamily="34" charset="-122"/>
@@ -2491,19 +2379,19 @@
               </a:rPr>
               <a:t>per message — the fee eats the word many times over</a:t>
             </a:r>
-            <a:endParaRPr lang="en-US" sz="1800" dirty="0"/>
-          </a:p>
-        </p:txBody>
-      </p:sp>
-      <p:sp>
-        <p:nvSpPr>
-          <p:cNvPr id="11" name="Text 9"/>
-          <p:cNvSpPr txBox="1"/>
-          <p:nvPr/>
-        </p:nvSpPr>
-        <p:spPr>
-          <a:xfrm>
-            <a:off x="548640" y="4471416"/>
+            <a:endParaRPr lang="en-US" sz="1700" dirty="0"/>
+          </a:p>
+        </p:txBody>
+      </p:sp>
+      <p:sp>
+        <p:nvSpPr>
+          <p:cNvPr id="10" name="Text 8"/>
+          <p:cNvSpPr txBox="1"/>
+          <p:nvPr/>
+        </p:nvSpPr>
+        <p:spPr>
+          <a:xfrm>
+            <a:off x="640080" y="4434840"/>
             <a:ext cx="4480560" cy="731520"/>
           </a:xfrm>
           <a:prstGeom prst="rect">
@@ -2536,14 +2424,14 @@
       </p:sp>
       <p:sp>
         <p:nvSpPr>
-          <p:cNvPr id="12" name="Text 10"/>
-          <p:cNvSpPr txBox="1"/>
-          <p:nvPr/>
-        </p:nvSpPr>
-        <p:spPr>
-          <a:xfrm>
-            <a:off x="5303520" y="4562856"/>
-            <a:ext cx="6309360" cy="731520"/>
+          <p:cNvPr id="11" name="Text 9"/>
+          <p:cNvSpPr txBox="1"/>
+          <p:nvPr/>
+        </p:nvSpPr>
+        <p:spPr>
+          <a:xfrm>
+            <a:off x="5394960" y="4544568"/>
+            <a:ext cx="6217920" cy="731520"/>
           </a:xfrm>
           <a:prstGeom prst="rect">
             <a:avLst/>
@@ -2557,14 +2445,14 @@
           <a:p>
             <a:pPr indent="0" marL="0">
               <a:lnSpc>
-                <a:spcPts val="2400"/>
+                <a:spcPts val="2300"/>
               </a:lnSpc>
               <a:buNone/>
             </a:pPr>
             <a:r>
-              <a:rPr lang="en-US" sz="1800" dirty="0">
-                <a:solidFill>
-                  <a:srgbClr val="71685A"/>
+              <a:rPr lang="en-US" sz="1700" dirty="0">
+                <a:solidFill>
+                  <a:srgbClr val="8A8274"/>
                 </a:solidFill>
                 <a:latin typeface="Georgia" pitchFamily="34" charset="0"/>
                 <a:ea typeface="Georgia" pitchFamily="34" charset="-122"/>
@@ -2572,61 +2460,38 @@
               </a:rPr>
               <a:t>bots flood a paid room faster than any server can ban them</a:t>
             </a:r>
-            <a:endParaRPr lang="en-US" sz="1800" dirty="0"/>
-          </a:p>
-        </p:txBody>
-      </p:sp>
-      <p:sp>
-        <p:nvSpPr>
-          <p:cNvPr id="13" name="Shape 11"/>
-          <p:cNvSpPr/>
-          <p:nvPr/>
-        </p:nvSpPr>
-        <p:spPr>
-          <a:xfrm>
-            <a:off x="548640" y="5577840"/>
-            <a:ext cx="11091672" cy="0"/>
-          </a:xfrm>
-          <a:prstGeom prst="line">
-            <a:avLst/>
-          </a:prstGeom>
-          <a:noFill/>
-          <a:ln w="12700">
-            <a:solidFill>
-              <a:srgbClr val="D8CDB8"/>
-            </a:solidFill>
-            <a:prstDash val="solid"/>
-          </a:ln>
-        </p:spPr>
-      </p:sp>
-      <p:sp>
-        <p:nvSpPr>
-          <p:cNvPr id="14" name="Text 12"/>
-          <p:cNvSpPr txBox="1"/>
-          <p:nvPr/>
-        </p:nvSpPr>
-        <p:spPr>
-          <a:xfrm>
-            <a:off x="548640" y="5760720"/>
-            <a:ext cx="11064240" cy="502920"/>
-          </a:xfrm>
-          <a:prstGeom prst="rect">
-            <a:avLst/>
-          </a:prstGeom>
-          <a:noFill/>
-          <a:ln/>
-        </p:spPr>
-        <p:txBody>
-          <a:bodyPr wrap="square" lIns="0" tIns="0" rIns="0" bIns="0" rtlCol="0" anchor="ctr"/>
-          <a:lstStyle/>
-          <a:p>
-            <a:pPr indent="0" marL="0">
-              <a:buNone/>
-            </a:pPr>
-            <a:r>
-              <a:rPr lang="en-US" sz="1900" i="1" dirty="0">
-                <a:solidFill>
-                  <a:srgbClr val="1A1712"/>
+            <a:endParaRPr lang="en-US" sz="1700" dirty="0"/>
+          </a:p>
+        </p:txBody>
+      </p:sp>
+      <p:sp>
+        <p:nvSpPr>
+          <p:cNvPr id="12" name="Text 10"/>
+          <p:cNvSpPr txBox="1"/>
+          <p:nvPr/>
+        </p:nvSpPr>
+        <p:spPr>
+          <a:xfrm>
+            <a:off x="640080" y="5897880"/>
+            <a:ext cx="10972800" cy="457200"/>
+          </a:xfrm>
+          <a:prstGeom prst="rect">
+            <a:avLst/>
+          </a:prstGeom>
+          <a:noFill/>
+          <a:ln/>
+        </p:spPr>
+        <p:txBody>
+          <a:bodyPr wrap="square" lIns="0" tIns="0" rIns="0" bIns="0" rtlCol="0" anchor="ctr"/>
+          <a:lstStyle/>
+          <a:p>
+            <a:pPr indent="0" marL="0">
+              <a:buNone/>
+            </a:pPr>
+            <a:r>
+              <a:rPr lang="en-US" sz="1700" i="1" dirty="0">
+                <a:solidFill>
+                  <a:srgbClr val="8A8274"/>
                 </a:solidFill>
                 <a:latin typeface="Georgia" pitchFamily="34" charset="0"/>
                 <a:ea typeface="Georgia" pitchFamily="34" charset="-122"/>
@@ -2634,7 +2499,7 @@
               </a:rPr>
               <a:t>“Every message is a payment” was an obvious idea no one could ship.</a:t>
             </a:r>
-            <a:endParaRPr lang="en-US" sz="1900" dirty="0"/>
+            <a:endParaRPr lang="en-US" sz="1700" dirty="0"/>
           </a:p>
         </p:txBody>
       </p:sp>
@@ -2652,7 +2517,7 @@
     <p:bg>
       <p:bgPr>
         <a:solidFill>
-          <a:srgbClr val="1A1712"/>
+          <a:srgbClr val="F4EFE6"/>
         </a:solidFill>
       </p:bgPr>
     </p:bg>
@@ -2678,26 +2543,26 @@
         </p:nvSpPr>
         <p:spPr>
           <a:xfrm>
-            <a:off x="548640" y="411480"/>
-            <a:ext cx="10424160" cy="502920"/>
-          </a:xfrm>
-          <a:prstGeom prst="rect">
-            <a:avLst/>
-          </a:prstGeom>
-          <a:noFill/>
-          <a:ln/>
-        </p:spPr>
-        <p:txBody>
-          <a:bodyPr wrap="square" lIns="0" tIns="0" rIns="0" bIns="0" rtlCol="0" anchor="ctr"/>
-          <a:lstStyle/>
-          <a:p>
-            <a:pPr indent="0" marL="0">
-              <a:buNone/>
-            </a:pPr>
-            <a:r>
-              <a:rPr lang="en-US" sz="1600" b="1" spc="300" kern="0" dirty="0">
-                <a:solidFill>
-                  <a:srgbClr val="F4EFE6"/>
+            <a:off x="640080" y="457200"/>
+            <a:ext cx="10058400" cy="365760"/>
+          </a:xfrm>
+          <a:prstGeom prst="rect">
+            <a:avLst/>
+          </a:prstGeom>
+          <a:noFill/>
+          <a:ln/>
+        </p:spPr>
+        <p:txBody>
+          <a:bodyPr wrap="square" lIns="0" tIns="0" rIns="0" bIns="0" rtlCol="0" anchor="ctr"/>
+          <a:lstStyle/>
+          <a:p>
+            <a:pPr indent="0" marL="0">
+              <a:buNone/>
+            </a:pPr>
+            <a:r>
+              <a:rPr lang="en-US" sz="1200" b="1" spc="300" kern="0" dirty="0">
+                <a:solidFill>
+                  <a:srgbClr val="8A8274"/>
                 </a:solidFill>
                 <a:latin typeface="Courier New" pitchFamily="34" charset="0"/>
                 <a:ea typeface="Courier New" pitchFamily="34" charset="-122"/>
@@ -2705,7 +2570,7 @@
               </a:rPr>
               <a:t>MONAD MAKES IT WORK</a:t>
             </a:r>
-            <a:endParaRPr lang="en-US" sz="1600" dirty="0"/>
+            <a:endParaRPr lang="en-US" sz="1200" dirty="0"/>
           </a:p>
         </p:txBody>
       </p:sp>
@@ -2717,8 +2582,8 @@
         </p:nvSpPr>
         <p:spPr>
           <a:xfrm>
-            <a:off x="11137392" y="411480"/>
-            <a:ext cx="502920" cy="502920"/>
+            <a:off x="11045952" y="457200"/>
+            <a:ext cx="502920" cy="365760"/>
           </a:xfrm>
           <a:prstGeom prst="rect">
             <a:avLst/>
@@ -2734,9 +2599,9 @@
               <a:buNone/>
             </a:pPr>
             <a:r>
-              <a:rPr lang="en-US" sz="1600" dirty="0">
-                <a:solidFill>
-                  <a:srgbClr val="BFB6A4"/>
+              <a:rPr lang="en-US" sz="1200" dirty="0">
+                <a:solidFill>
+                  <a:srgbClr val="8A8274"/>
                 </a:solidFill>
                 <a:latin typeface="Courier New" pitchFamily="34" charset="0"/>
                 <a:ea typeface="Courier New" pitchFamily="34" charset="-122"/>
@@ -2744,42 +2609,19 @@
               </a:rPr>
               <a:t>04</a:t>
             </a:r>
-            <a:endParaRPr lang="en-US" sz="1600" dirty="0"/>
-          </a:p>
-        </p:txBody>
-      </p:sp>
-      <p:sp>
-        <p:nvSpPr>
-          <p:cNvPr id="4" name="Shape 2"/>
-          <p:cNvSpPr/>
-          <p:nvPr/>
-        </p:nvSpPr>
-        <p:spPr>
-          <a:xfrm>
-            <a:off x="548640" y="960120"/>
-            <a:ext cx="11091672" cy="0"/>
-          </a:xfrm>
-          <a:prstGeom prst="line">
-            <a:avLst/>
-          </a:prstGeom>
-          <a:noFill/>
-          <a:ln w="15240">
-            <a:solidFill>
-              <a:srgbClr val="4A443A"/>
-            </a:solidFill>
-            <a:prstDash val="solid"/>
-          </a:ln>
-        </p:spPr>
-      </p:sp>
-      <p:sp>
-        <p:nvSpPr>
-          <p:cNvPr id="5" name="Text 3"/>
-          <p:cNvSpPr txBox="1"/>
-          <p:nvPr/>
-        </p:nvSpPr>
-        <p:spPr>
-          <a:xfrm>
-            <a:off x="548640" y="1325880"/>
+            <a:endParaRPr lang="en-US" sz="1200" dirty="0"/>
+          </a:p>
+        </p:txBody>
+      </p:sp>
+      <p:sp>
+        <p:nvSpPr>
+          <p:cNvPr id="4" name="Text 2"/>
+          <p:cNvSpPr txBox="1"/>
+          <p:nvPr/>
+        </p:nvSpPr>
+        <p:spPr>
+          <a:xfrm>
+            <a:off x="640080" y="1280160"/>
             <a:ext cx="4480560" cy="868680"/>
           </a:xfrm>
           <a:prstGeom prst="rect">
@@ -2796,7 +2638,7 @@
               <a:buNone/>
             </a:pPr>
             <a:r>
-              <a:rPr lang="en-US" sz="4600" dirty="0">
+              <a:rPr lang="en-US" sz="4400" dirty="0">
                 <a:solidFill>
                   <a:srgbClr val="BF3A1E"/>
                 </a:solidFill>
@@ -2806,20 +2648,20 @@
               </a:rPr>
               <a:t>0.5s</a:t>
             </a:r>
-            <a:endParaRPr lang="en-US" sz="4600" dirty="0"/>
-          </a:p>
-        </p:txBody>
-      </p:sp>
-      <p:sp>
-        <p:nvSpPr>
-          <p:cNvPr id="6" name="Text 4"/>
-          <p:cNvSpPr txBox="1"/>
-          <p:nvPr/>
-        </p:nvSpPr>
-        <p:spPr>
-          <a:xfrm>
-            <a:off x="5303520" y="1490472"/>
-            <a:ext cx="6309360" cy="868680"/>
+            <a:endParaRPr lang="en-US" sz="4400" dirty="0"/>
+          </a:p>
+        </p:txBody>
+      </p:sp>
+      <p:sp>
+        <p:nvSpPr>
+          <p:cNvPr id="5" name="Text 3"/>
+          <p:cNvSpPr txBox="1"/>
+          <p:nvPr/>
+        </p:nvSpPr>
+        <p:spPr>
+          <a:xfrm>
+            <a:off x="5394960" y="1444752"/>
+            <a:ext cx="6217920" cy="868680"/>
           </a:xfrm>
           <a:prstGeom prst="rect">
             <a:avLst/>
@@ -2833,14 +2675,14 @@
           <a:p>
             <a:pPr indent="0" marL="0">
               <a:lnSpc>
-                <a:spcPts val="2400"/>
+                <a:spcPts val="2300"/>
               </a:lnSpc>
               <a:buNone/>
             </a:pPr>
             <a:r>
-              <a:rPr lang="en-US" sz="1800" dirty="0">
-                <a:solidFill>
-                  <a:srgbClr val="E5DFD2"/>
+              <a:rPr lang="en-US" sz="1700" dirty="0">
+                <a:solidFill>
+                  <a:srgbClr val="1A1712"/>
                 </a:solidFill>
                 <a:latin typeface="Georgia" pitchFamily="34" charset="0"/>
                 <a:ea typeface="Georgia" pitchFamily="34" charset="-122"/>
@@ -2848,19 +2690,19 @@
               </a:rPr>
               <a:t>a message lands on chain before the reply is typed — we measured it, live, today</a:t>
             </a:r>
-            <a:endParaRPr lang="en-US" sz="1800" dirty="0"/>
-          </a:p>
-        </p:txBody>
-      </p:sp>
-      <p:sp>
-        <p:nvSpPr>
-          <p:cNvPr id="7" name="Text 5"/>
-          <p:cNvSpPr txBox="1"/>
-          <p:nvPr/>
-        </p:nvSpPr>
-        <p:spPr>
-          <a:xfrm>
-            <a:off x="548640" y="2496312"/>
+            <a:endParaRPr lang="en-US" sz="1700" dirty="0"/>
+          </a:p>
+        </p:txBody>
+      </p:sp>
+      <p:sp>
+        <p:nvSpPr>
+          <p:cNvPr id="6" name="Text 4"/>
+          <p:cNvSpPr txBox="1"/>
+          <p:nvPr/>
+        </p:nvSpPr>
+        <p:spPr>
+          <a:xfrm>
+            <a:off x="640080" y="2450592"/>
             <a:ext cx="4480560" cy="868680"/>
           </a:xfrm>
           <a:prstGeom prst="rect">
@@ -2877,9 +2719,9 @@
               <a:buNone/>
             </a:pPr>
             <a:r>
-              <a:rPr lang="en-US" sz="4600" dirty="0">
-                <a:solidFill>
-                  <a:srgbClr val="F4EFE6"/>
+              <a:rPr lang="en-US" sz="4400" dirty="0">
+                <a:solidFill>
+                  <a:srgbClr val="BF3A1E"/>
                 </a:solidFill>
                 <a:latin typeface="Alsina" pitchFamily="34" charset="0"/>
                 <a:ea typeface="Alsina" pitchFamily="34" charset="-122"/>
@@ -2887,20 +2729,20 @@
               </a:rPr>
               <a:t>~$0 fees</a:t>
             </a:r>
-            <a:endParaRPr lang="en-US" sz="4600" dirty="0"/>
-          </a:p>
-        </p:txBody>
-      </p:sp>
-      <p:sp>
-        <p:nvSpPr>
-          <p:cNvPr id="8" name="Text 6"/>
-          <p:cNvSpPr txBox="1"/>
-          <p:nvPr/>
-        </p:nvSpPr>
-        <p:spPr>
-          <a:xfrm>
-            <a:off x="5303520" y="2660904"/>
-            <a:ext cx="6309360" cy="868680"/>
+            <a:endParaRPr lang="en-US" sz="4400" dirty="0"/>
+          </a:p>
+        </p:txBody>
+      </p:sp>
+      <p:sp>
+        <p:nvSpPr>
+          <p:cNvPr id="7" name="Text 5"/>
+          <p:cNvSpPr txBox="1"/>
+          <p:nvPr/>
+        </p:nvSpPr>
+        <p:spPr>
+          <a:xfrm>
+            <a:off x="5394960" y="2615184"/>
+            <a:ext cx="6217920" cy="868680"/>
           </a:xfrm>
           <a:prstGeom prst="rect">
             <a:avLst/>
@@ -2914,14 +2756,14 @@
           <a:p>
             <a:pPr indent="0" marL="0">
               <a:lnSpc>
-                <a:spcPts val="2400"/>
+                <a:spcPts val="2300"/>
               </a:lnSpc>
               <a:buNone/>
             </a:pPr>
             <a:r>
-              <a:rPr lang="en-US" sz="1800" dirty="0">
-                <a:solidFill>
-                  <a:srgbClr val="E5DFD2"/>
+              <a:rPr lang="en-US" sz="1700" dirty="0">
+                <a:solidFill>
+                  <a:srgbClr val="1A1712"/>
                 </a:solidFill>
                 <a:latin typeface="Georgia" pitchFamily="34" charset="0"/>
                 <a:ea typeface="Georgia" pitchFamily="34" charset="-122"/>
@@ -2929,19 +2771,19 @@
               </a:rPr>
               <a:t>the rail costs a fraction of the word — streamers keep the money</a:t>
             </a:r>
-            <a:endParaRPr lang="en-US" sz="1800" dirty="0"/>
-          </a:p>
-        </p:txBody>
-      </p:sp>
-      <p:sp>
-        <p:nvSpPr>
-          <p:cNvPr id="9" name="Text 7"/>
-          <p:cNvSpPr txBox="1"/>
-          <p:nvPr/>
-        </p:nvSpPr>
-        <p:spPr>
-          <a:xfrm>
-            <a:off x="548640" y="3666744"/>
+            <a:endParaRPr lang="en-US" sz="1700" dirty="0"/>
+          </a:p>
+        </p:txBody>
+      </p:sp>
+      <p:sp>
+        <p:nvSpPr>
+          <p:cNvPr id="8" name="Text 6"/>
+          <p:cNvSpPr txBox="1"/>
+          <p:nvPr/>
+        </p:nvSpPr>
+        <p:spPr>
+          <a:xfrm>
+            <a:off x="640080" y="3621024"/>
             <a:ext cx="4480560" cy="868680"/>
           </a:xfrm>
           <a:prstGeom prst="rect">
@@ -2958,9 +2800,9 @@
               <a:buNone/>
             </a:pPr>
             <a:r>
-              <a:rPr lang="en-US" sz="4600" dirty="0">
-                <a:solidFill>
-                  <a:srgbClr val="F4EFE6"/>
+              <a:rPr lang="en-US" sz="4400" dirty="0">
+                <a:solidFill>
+                  <a:srgbClr val="BF3A1E"/>
                 </a:solidFill>
                 <a:latin typeface="Alsina" pitchFamily="34" charset="0"/>
                 <a:ea typeface="Alsina" pitchFamily="34" charset="-122"/>
@@ -2968,20 +2810,20 @@
               </a:rPr>
               <a:t>10,000 TPS</a:t>
             </a:r>
-            <a:endParaRPr lang="en-US" sz="4600" dirty="0"/>
-          </a:p>
-        </p:txBody>
-      </p:sp>
-      <p:sp>
-        <p:nvSpPr>
-          <p:cNvPr id="10" name="Text 8"/>
-          <p:cNvSpPr txBox="1"/>
-          <p:nvPr/>
-        </p:nvSpPr>
-        <p:spPr>
-          <a:xfrm>
-            <a:off x="5303520" y="3831336"/>
-            <a:ext cx="6309360" cy="868680"/>
+            <a:endParaRPr lang="en-US" sz="4400" dirty="0"/>
+          </a:p>
+        </p:txBody>
+      </p:sp>
+      <p:sp>
+        <p:nvSpPr>
+          <p:cNvPr id="9" name="Text 7"/>
+          <p:cNvSpPr txBox="1"/>
+          <p:nvPr/>
+        </p:nvSpPr>
+        <p:spPr>
+          <a:xfrm>
+            <a:off x="5394960" y="3785616"/>
+            <a:ext cx="6217920" cy="868680"/>
           </a:xfrm>
           <a:prstGeom prst="rect">
             <a:avLst/>
@@ -2995,14 +2837,14 @@
           <a:p>
             <a:pPr indent="0" marL="0">
               <a:lnSpc>
-                <a:spcPts val="2400"/>
+                <a:spcPts val="2300"/>
               </a:lnSpc>
               <a:buNone/>
             </a:pPr>
             <a:r>
-              <a:rPr lang="en-US" sz="1800" dirty="0">
-                <a:solidFill>
-                  <a:srgbClr val="E5DFD2"/>
+              <a:rPr lang="en-US" sz="1700" dirty="0">
+                <a:solidFill>
+                  <a:srgbClr val="1A1712"/>
                 </a:solidFill>
                 <a:latin typeface="Georgia" pitchFamily="34" charset="0"/>
                 <a:ea typeface="Georgia" pitchFamily="34" charset="-122"/>
@@ -3010,19 +2852,19 @@
               </a:rPr>
               <a:t>an entire platform's chat is normal load, not an attack</a:t>
             </a:r>
-            <a:endParaRPr lang="en-US" sz="1800" dirty="0"/>
-          </a:p>
-        </p:txBody>
-      </p:sp>
-      <p:sp>
-        <p:nvSpPr>
-          <p:cNvPr id="11" name="Text 9"/>
-          <p:cNvSpPr txBox="1"/>
-          <p:nvPr/>
-        </p:nvSpPr>
-        <p:spPr>
-          <a:xfrm>
-            <a:off x="548640" y="4837176"/>
+            <a:endParaRPr lang="en-US" sz="1700" dirty="0"/>
+          </a:p>
+        </p:txBody>
+      </p:sp>
+      <p:sp>
+        <p:nvSpPr>
+          <p:cNvPr id="10" name="Text 8"/>
+          <p:cNvSpPr txBox="1"/>
+          <p:nvPr/>
+        </p:nvSpPr>
+        <p:spPr>
+          <a:xfrm>
+            <a:off x="640080" y="4791456"/>
             <a:ext cx="4480560" cy="868680"/>
           </a:xfrm>
           <a:prstGeom prst="rect">
@@ -3039,9 +2881,9 @@
               <a:buNone/>
             </a:pPr>
             <a:r>
-              <a:rPr lang="en-US" sz="4600" dirty="0">
-                <a:solidFill>
-                  <a:srgbClr val="F4EFE6"/>
+              <a:rPr lang="en-US" sz="4400" dirty="0">
+                <a:solidFill>
+                  <a:srgbClr val="BF3A1E"/>
                 </a:solidFill>
                 <a:latin typeface="Alsina" pitchFamily="34" charset="0"/>
                 <a:ea typeface="Alsina" pitchFamily="34" charset="-122"/>
@@ -3049,20 +2891,20 @@
               </a:rPr>
               <a:t>spam self-destructs</a:t>
             </a:r>
-            <a:endParaRPr lang="en-US" sz="4600" dirty="0"/>
-          </a:p>
-        </p:txBody>
-      </p:sp>
-      <p:sp>
-        <p:nvSpPr>
-          <p:cNvPr id="12" name="Text 10"/>
-          <p:cNvSpPr txBox="1"/>
-          <p:nvPr/>
-        </p:nvSpPr>
-        <p:spPr>
-          <a:xfrm>
-            <a:off x="5303520" y="5001768"/>
-            <a:ext cx="6309360" cy="868680"/>
+            <a:endParaRPr lang="en-US" sz="4400" dirty="0"/>
+          </a:p>
+        </p:txBody>
+      </p:sp>
+      <p:sp>
+        <p:nvSpPr>
+          <p:cNvPr id="11" name="Text 9"/>
+          <p:cNvSpPr txBox="1"/>
+          <p:nvPr/>
+        </p:nvSpPr>
+        <p:spPr>
+          <a:xfrm>
+            <a:off x="5394960" y="4956048"/>
+            <a:ext cx="6217920" cy="868680"/>
           </a:xfrm>
           <a:prstGeom prst="rect">
             <a:avLst/>
@@ -3076,14 +2918,14 @@
           <a:p>
             <a:pPr indent="0" marL="0">
               <a:lnSpc>
-                <a:spcPts val="2400"/>
+                <a:spcPts val="2300"/>
               </a:lnSpc>
               <a:buNone/>
             </a:pPr>
             <a:r>
-              <a:rPr lang="en-US" sz="1800" dirty="0">
-                <a:solidFill>
-                  <a:srgbClr val="E5DFD2"/>
+              <a:rPr lang="en-US" sz="1700" dirty="0">
+                <a:solidFill>
+                  <a:srgbClr val="1A1712"/>
                 </a:solidFill>
                 <a:latin typeface="Georgia" pitchFamily="34" charset="0"/>
                 <a:ea typeface="Georgia" pitchFamily="34" charset="-122"/>
@@ -3091,7 +2933,7 @@
               </a:rPr>
               <a:t>the network rate-limits every wallet — spamming burns the spammer’s own gas</a:t>
             </a:r>
-            <a:endParaRPr lang="en-US" sz="1800" dirty="0"/>
+            <a:endParaRPr lang="en-US" sz="1700" dirty="0"/>
           </a:p>
         </p:txBody>
       </p:sp>
@@ -3135,26 +2977,26 @@
         </p:nvSpPr>
         <p:spPr>
           <a:xfrm>
-            <a:off x="548640" y="411480"/>
-            <a:ext cx="10424160" cy="502920"/>
-          </a:xfrm>
-          <a:prstGeom prst="rect">
-            <a:avLst/>
-          </a:prstGeom>
-          <a:noFill/>
-          <a:ln/>
-        </p:spPr>
-        <p:txBody>
-          <a:bodyPr wrap="square" lIns="0" tIns="0" rIns="0" bIns="0" rtlCol="0" anchor="ctr"/>
-          <a:lstStyle/>
-          <a:p>
-            <a:pPr indent="0" marL="0">
-              <a:buNone/>
-            </a:pPr>
-            <a:r>
-              <a:rPr lang="en-US" sz="1600" b="1" spc="300" kern="0" dirty="0">
-                <a:solidFill>
-                  <a:srgbClr val="1A1712"/>
+            <a:off x="640080" y="457200"/>
+            <a:ext cx="10058400" cy="365760"/>
+          </a:xfrm>
+          <a:prstGeom prst="rect">
+            <a:avLst/>
+          </a:prstGeom>
+          <a:noFill/>
+          <a:ln/>
+        </p:spPr>
+        <p:txBody>
+          <a:bodyPr wrap="square" lIns="0" tIns="0" rIns="0" bIns="0" rtlCol="0" anchor="ctr"/>
+          <a:lstStyle/>
+          <a:p>
+            <a:pPr indent="0" marL="0">
+              <a:buNone/>
+            </a:pPr>
+            <a:r>
+              <a:rPr lang="en-US" sz="1200" b="1" spc="300" kern="0" dirty="0">
+                <a:solidFill>
+                  <a:srgbClr val="8A8274"/>
                 </a:solidFill>
                 <a:latin typeface="Courier New" pitchFamily="34" charset="0"/>
                 <a:ea typeface="Courier New" pitchFamily="34" charset="-122"/>
@@ -3162,7 +3004,7 @@
               </a:rPr>
               <a:t>HOW MONADCHAT WORKS</a:t>
             </a:r>
-            <a:endParaRPr lang="en-US" sz="1600" dirty="0"/>
+            <a:endParaRPr lang="en-US" sz="1200" dirty="0"/>
           </a:p>
         </p:txBody>
       </p:sp>
@@ -3174,8 +3016,8 @@
         </p:nvSpPr>
         <p:spPr>
           <a:xfrm>
-            <a:off x="11137392" y="411480"/>
-            <a:ext cx="502920" cy="502920"/>
+            <a:off x="11045952" y="457200"/>
+            <a:ext cx="502920" cy="365760"/>
           </a:xfrm>
           <a:prstGeom prst="rect">
             <a:avLst/>
@@ -3191,9 +3033,9 @@
               <a:buNone/>
             </a:pPr>
             <a:r>
-              <a:rPr lang="en-US" sz="1600" dirty="0">
-                <a:solidFill>
-                  <a:srgbClr val="71685A"/>
+              <a:rPr lang="en-US" sz="1200" dirty="0">
+                <a:solidFill>
+                  <a:srgbClr val="8A8274"/>
                 </a:solidFill>
                 <a:latin typeface="Courier New" pitchFamily="34" charset="0"/>
                 <a:ea typeface="Courier New" pitchFamily="34" charset="-122"/>
@@ -3201,42 +3043,19 @@
               </a:rPr>
               <a:t>05</a:t>
             </a:r>
-            <a:endParaRPr lang="en-US" sz="1600" dirty="0"/>
-          </a:p>
-        </p:txBody>
-      </p:sp>
-      <p:sp>
-        <p:nvSpPr>
-          <p:cNvPr id="4" name="Shape 2"/>
-          <p:cNvSpPr/>
-          <p:nvPr/>
-        </p:nvSpPr>
-        <p:spPr>
-          <a:xfrm>
-            <a:off x="548640" y="960120"/>
-            <a:ext cx="11091672" cy="0"/>
-          </a:xfrm>
-          <a:prstGeom prst="line">
-            <a:avLst/>
-          </a:prstGeom>
-          <a:noFill/>
-          <a:ln w="15240">
-            <a:solidFill>
-              <a:srgbClr val="1A1712"/>
-            </a:solidFill>
-            <a:prstDash val="solid"/>
-          </a:ln>
-        </p:spPr>
-      </p:sp>
-      <p:sp>
-        <p:nvSpPr>
-          <p:cNvPr id="5" name="Text 3"/>
-          <p:cNvSpPr txBox="1"/>
-          <p:nvPr/>
-        </p:nvSpPr>
-        <p:spPr>
-          <a:xfrm>
-            <a:off x="548640" y="1417320"/>
+            <a:endParaRPr lang="en-US" sz="1200" dirty="0"/>
+          </a:p>
+        </p:txBody>
+      </p:sp>
+      <p:sp>
+        <p:nvSpPr>
+          <p:cNvPr id="4" name="Text 2"/>
+          <p:cNvSpPr txBox="1"/>
+          <p:nvPr/>
+        </p:nvSpPr>
+        <p:spPr>
+          <a:xfrm>
+            <a:off x="640080" y="1344168"/>
             <a:ext cx="822960" cy="1005840"/>
           </a:xfrm>
           <a:prstGeom prst="rect">
@@ -3253,9 +3072,9 @@
               <a:buNone/>
             </a:pPr>
             <a:r>
-              <a:rPr lang="en-US" sz="6000" dirty="0">
-                <a:solidFill>
-                  <a:srgbClr val="BF3A1E"/>
+              <a:rPr lang="en-US" sz="5600" dirty="0">
+                <a:solidFill>
+                  <a:srgbClr val="8A8274"/>
                 </a:solidFill>
                 <a:latin typeface="Alsina" pitchFamily="34" charset="0"/>
                 <a:ea typeface="Alsina" pitchFamily="34" charset="-122"/>
@@ -3263,36 +3082,36 @@
               </a:rPr>
               <a:t>1</a:t>
             </a:r>
-            <a:endParaRPr lang="en-US" sz="6000" dirty="0"/>
-          </a:p>
-        </p:txBody>
-      </p:sp>
-      <p:sp>
-        <p:nvSpPr>
-          <p:cNvPr id="6" name="Text 4"/>
-          <p:cNvSpPr txBox="1"/>
-          <p:nvPr/>
-        </p:nvSpPr>
-        <p:spPr>
-          <a:xfrm>
-            <a:off x="1600200" y="1508760"/>
-            <a:ext cx="6949440" cy="548640"/>
-          </a:xfrm>
-          <a:prstGeom prst="rect">
-            <a:avLst/>
-          </a:prstGeom>
-          <a:noFill/>
-          <a:ln/>
-        </p:spPr>
-        <p:txBody>
-          <a:bodyPr wrap="square" lIns="0" tIns="0" rIns="0" bIns="0" rtlCol="0" anchor="ctr"/>
-          <a:lstStyle/>
-          <a:p>
-            <a:pPr indent="0" marL="0">
-              <a:buNone/>
-            </a:pPr>
-            <a:r>
-              <a:rPr lang="en-US" sz="2500" b="1" dirty="0">
+            <a:endParaRPr lang="en-US" sz="5600" dirty="0"/>
+          </a:p>
+        </p:txBody>
+      </p:sp>
+      <p:sp>
+        <p:nvSpPr>
+          <p:cNvPr id="5" name="Text 3"/>
+          <p:cNvSpPr txBox="1"/>
+          <p:nvPr/>
+        </p:nvSpPr>
+        <p:spPr>
+          <a:xfrm>
+            <a:off x="1645920" y="1417320"/>
+            <a:ext cx="9875520" cy="548640"/>
+          </a:xfrm>
+          <a:prstGeom prst="rect">
+            <a:avLst/>
+          </a:prstGeom>
+          <a:noFill/>
+          <a:ln/>
+        </p:spPr>
+        <p:txBody>
+          <a:bodyPr wrap="square" lIns="0" tIns="0" rIns="0" bIns="0" rtlCol="0" anchor="ctr"/>
+          <a:lstStyle/>
+          <a:p>
+            <a:pPr indent="0" marL="0">
+              <a:buNone/>
+            </a:pPr>
+            <a:r>
+              <a:rPr lang="en-US" sz="2400" b="1" dirty="0">
                 <a:solidFill>
                   <a:srgbClr val="1A1712"/>
                 </a:solidFill>
@@ -3302,38 +3121,38 @@
               </a:rPr>
               <a:t>A fan pays per word</a:t>
             </a:r>
-            <a:endParaRPr lang="en-US" sz="2500" dirty="0"/>
-          </a:p>
-        </p:txBody>
-      </p:sp>
-      <p:sp>
-        <p:nvSpPr>
-          <p:cNvPr id="7" name="Text 5"/>
-          <p:cNvSpPr txBox="1"/>
-          <p:nvPr/>
-        </p:nvSpPr>
-        <p:spPr>
-          <a:xfrm>
-            <a:off x="1600200" y="2075688"/>
-            <a:ext cx="9601200" cy="502920"/>
-          </a:xfrm>
-          <a:prstGeom prst="rect">
-            <a:avLst/>
-          </a:prstGeom>
-          <a:noFill/>
-          <a:ln/>
-        </p:spPr>
-        <p:txBody>
-          <a:bodyPr wrap="square" lIns="0" tIns="0" rIns="0" bIns="0" rtlCol="0" anchor="ctr"/>
-          <a:lstStyle/>
-          <a:p>
-            <a:pPr indent="0" marL="0">
-              <a:buNone/>
-            </a:pPr>
-            <a:r>
-              <a:rPr lang="en-US" sz="1700" dirty="0">
-                <a:solidFill>
-                  <a:srgbClr val="71685A"/>
+            <a:endParaRPr lang="en-US" sz="2400" dirty="0"/>
+          </a:p>
+        </p:txBody>
+      </p:sp>
+      <p:sp>
+        <p:nvSpPr>
+          <p:cNvPr id="6" name="Text 4"/>
+          <p:cNvSpPr txBox="1"/>
+          <p:nvPr/>
+        </p:nvSpPr>
+        <p:spPr>
+          <a:xfrm>
+            <a:off x="1645920" y="1965960"/>
+            <a:ext cx="9875520" cy="502920"/>
+          </a:xfrm>
+          <a:prstGeom prst="rect">
+            <a:avLst/>
+          </a:prstGeom>
+          <a:noFill/>
+          <a:ln/>
+        </p:spPr>
+        <p:txBody>
+          <a:bodyPr wrap="square" lIns="0" tIns="0" rIns="0" bIns="0" rtlCol="0" anchor="ctr"/>
+          <a:lstStyle/>
+          <a:p>
+            <a:pPr indent="0" marL="0">
+              <a:buNone/>
+            </a:pPr>
+            <a:r>
+              <a:rPr lang="en-US" sz="1600" dirty="0">
+                <a:solidFill>
+                  <a:srgbClr val="8A8274"/>
                 </a:solidFill>
                 <a:latin typeface="Georgia" pitchFamily="34" charset="0"/>
                 <a:ea typeface="Georgia" pitchFamily="34" charset="-122"/>
@@ -3341,19 +3160,19 @@
               </a:rPr>
               <a:t>no wallet setup — the browser creates one; typing in ten seconds</a:t>
             </a:r>
-            <a:endParaRPr lang="en-US" sz="1700" dirty="0"/>
-          </a:p>
-        </p:txBody>
-      </p:sp>
-      <p:sp>
-        <p:nvSpPr>
-          <p:cNvPr id="8" name="Text 6"/>
-          <p:cNvSpPr txBox="1"/>
-          <p:nvPr/>
-        </p:nvSpPr>
-        <p:spPr>
-          <a:xfrm>
-            <a:off x="548640" y="2834640"/>
+            <a:endParaRPr lang="en-US" sz="1600" dirty="0"/>
+          </a:p>
+        </p:txBody>
+      </p:sp>
+      <p:sp>
+        <p:nvSpPr>
+          <p:cNvPr id="7" name="Text 5"/>
+          <p:cNvSpPr txBox="1"/>
+          <p:nvPr/>
+        </p:nvSpPr>
+        <p:spPr>
+          <a:xfrm>
+            <a:off x="640080" y="2761488"/>
             <a:ext cx="822960" cy="1005840"/>
           </a:xfrm>
           <a:prstGeom prst="rect">
@@ -3370,9 +3189,9 @@
               <a:buNone/>
             </a:pPr>
             <a:r>
-              <a:rPr lang="en-US" sz="6000" dirty="0">
-                <a:solidFill>
-                  <a:srgbClr val="BF3A1E"/>
+              <a:rPr lang="en-US" sz="5600" dirty="0">
+                <a:solidFill>
+                  <a:srgbClr val="8A8274"/>
                 </a:solidFill>
                 <a:latin typeface="Alsina" pitchFamily="34" charset="0"/>
                 <a:ea typeface="Alsina" pitchFamily="34" charset="-122"/>
@@ -3380,36 +3199,36 @@
               </a:rPr>
               <a:t>2</a:t>
             </a:r>
-            <a:endParaRPr lang="en-US" sz="6000" dirty="0"/>
-          </a:p>
-        </p:txBody>
-      </p:sp>
-      <p:sp>
-        <p:nvSpPr>
-          <p:cNvPr id="9" name="Text 7"/>
-          <p:cNvSpPr txBox="1"/>
-          <p:nvPr/>
-        </p:nvSpPr>
-        <p:spPr>
-          <a:xfrm>
-            <a:off x="1600200" y="2926080"/>
-            <a:ext cx="6949440" cy="548640"/>
-          </a:xfrm>
-          <a:prstGeom prst="rect">
-            <a:avLst/>
-          </a:prstGeom>
-          <a:noFill/>
-          <a:ln/>
-        </p:spPr>
-        <p:txBody>
-          <a:bodyPr wrap="square" lIns="0" tIns="0" rIns="0" bIns="0" rtlCol="0" anchor="ctr"/>
-          <a:lstStyle/>
-          <a:p>
-            <a:pPr indent="0" marL="0">
-              <a:buNone/>
-            </a:pPr>
-            <a:r>
-              <a:rPr lang="en-US" sz="2500" b="1" dirty="0">
+            <a:endParaRPr lang="en-US" sz="5600" dirty="0"/>
+          </a:p>
+        </p:txBody>
+      </p:sp>
+      <p:sp>
+        <p:nvSpPr>
+          <p:cNvPr id="8" name="Text 6"/>
+          <p:cNvSpPr txBox="1"/>
+          <p:nvPr/>
+        </p:nvSpPr>
+        <p:spPr>
+          <a:xfrm>
+            <a:off x="1645920" y="2834640"/>
+            <a:ext cx="9875520" cy="548640"/>
+          </a:xfrm>
+          <a:prstGeom prst="rect">
+            <a:avLst/>
+          </a:prstGeom>
+          <a:noFill/>
+          <a:ln/>
+        </p:spPr>
+        <p:txBody>
+          <a:bodyPr wrap="square" lIns="0" tIns="0" rIns="0" bIns="0" rtlCol="0" anchor="ctr"/>
+          <a:lstStyle/>
+          <a:p>
+            <a:pPr indent="0" marL="0">
+              <a:buNone/>
+            </a:pPr>
+            <a:r>
+              <a:rPr lang="en-US" sz="2400" b="1" dirty="0">
                 <a:solidFill>
                   <a:srgbClr val="1A1712"/>
                 </a:solidFill>
@@ -3419,38 +3238,38 @@
               </a:rPr>
               <a:t>The streamer is paid the same second</a:t>
             </a:r>
-            <a:endParaRPr lang="en-US" sz="2500" dirty="0"/>
-          </a:p>
-        </p:txBody>
-      </p:sp>
-      <p:sp>
-        <p:nvSpPr>
-          <p:cNvPr id="10" name="Text 8"/>
-          <p:cNvSpPr txBox="1"/>
-          <p:nvPr/>
-        </p:nvSpPr>
-        <p:spPr>
-          <a:xfrm>
-            <a:off x="1600200" y="3493008"/>
-            <a:ext cx="9601200" cy="502920"/>
-          </a:xfrm>
-          <a:prstGeom prst="rect">
-            <a:avLst/>
-          </a:prstGeom>
-          <a:noFill/>
-          <a:ln/>
-        </p:spPr>
-        <p:txBody>
-          <a:bodyPr wrap="square" lIns="0" tIns="0" rIns="0" bIns="0" rtlCol="0" anchor="ctr"/>
-          <a:lstStyle/>
-          <a:p>
-            <a:pPr indent="0" marL="0">
-              <a:buNone/>
-            </a:pPr>
-            <a:r>
-              <a:rPr lang="en-US" sz="1700" dirty="0">
-                <a:solidFill>
-                  <a:srgbClr val="71685A"/>
+            <a:endParaRPr lang="en-US" sz="2400" dirty="0"/>
+          </a:p>
+        </p:txBody>
+      </p:sp>
+      <p:sp>
+        <p:nvSpPr>
+          <p:cNvPr id="9" name="Text 7"/>
+          <p:cNvSpPr txBox="1"/>
+          <p:nvPr/>
+        </p:nvSpPr>
+        <p:spPr>
+          <a:xfrm>
+            <a:off x="1645920" y="3383280"/>
+            <a:ext cx="9875520" cy="502920"/>
+          </a:xfrm>
+          <a:prstGeom prst="rect">
+            <a:avLst/>
+          </a:prstGeom>
+          <a:noFill/>
+          <a:ln/>
+        </p:spPr>
+        <p:txBody>
+          <a:bodyPr wrap="square" lIns="0" tIns="0" rIns="0" bIns="0" rtlCol="0" anchor="ctr"/>
+          <a:lstStyle/>
+          <a:p>
+            <a:pPr indent="0" marL="0">
+              <a:buNone/>
+            </a:pPr>
+            <a:r>
+              <a:rPr lang="en-US" sz="1600" dirty="0">
+                <a:solidFill>
+                  <a:srgbClr val="8A8274"/>
                 </a:solidFill>
                 <a:latin typeface="Georgia" pitchFamily="34" charset="0"/>
                 <a:ea typeface="Georgia" pitchFamily="34" charset="-122"/>
@@ -3458,19 +3277,19 @@
               </a:rPr>
               <a:t>100% of the price, straight to their wallet — no payout day</a:t>
             </a:r>
-            <a:endParaRPr lang="en-US" sz="1700" dirty="0"/>
-          </a:p>
-        </p:txBody>
-      </p:sp>
-      <p:sp>
-        <p:nvSpPr>
-          <p:cNvPr id="11" name="Text 9"/>
-          <p:cNvSpPr txBox="1"/>
-          <p:nvPr/>
-        </p:nvSpPr>
-        <p:spPr>
-          <a:xfrm>
-            <a:off x="548640" y="4251960"/>
+            <a:endParaRPr lang="en-US" sz="1600" dirty="0"/>
+          </a:p>
+        </p:txBody>
+      </p:sp>
+      <p:sp>
+        <p:nvSpPr>
+          <p:cNvPr id="10" name="Text 8"/>
+          <p:cNvSpPr txBox="1"/>
+          <p:nvPr/>
+        </p:nvSpPr>
+        <p:spPr>
+          <a:xfrm>
+            <a:off x="640080" y="4178808"/>
             <a:ext cx="822960" cy="1005840"/>
           </a:xfrm>
           <a:prstGeom prst="rect">
@@ -3487,9 +3306,9 @@
               <a:buNone/>
             </a:pPr>
             <a:r>
-              <a:rPr lang="en-US" sz="6000" dirty="0">
-                <a:solidFill>
-                  <a:srgbClr val="BF3A1E"/>
+              <a:rPr lang="en-US" sz="5600" dirty="0">
+                <a:solidFill>
+                  <a:srgbClr val="8A8274"/>
                 </a:solidFill>
                 <a:latin typeface="Alsina" pitchFamily="34" charset="0"/>
                 <a:ea typeface="Alsina" pitchFamily="34" charset="-122"/>
@@ -3497,36 +3316,36 @@
               </a:rPr>
               <a:t>3</a:t>
             </a:r>
-            <a:endParaRPr lang="en-US" sz="6000" dirty="0"/>
-          </a:p>
-        </p:txBody>
-      </p:sp>
-      <p:sp>
-        <p:nvSpPr>
-          <p:cNvPr id="12" name="Text 10"/>
-          <p:cNvSpPr txBox="1"/>
-          <p:nvPr/>
-        </p:nvSpPr>
-        <p:spPr>
-          <a:xfrm>
-            <a:off x="1600200" y="4343400"/>
-            <a:ext cx="6949440" cy="548640"/>
-          </a:xfrm>
-          <a:prstGeom prst="rect">
-            <a:avLst/>
-          </a:prstGeom>
-          <a:noFill/>
-          <a:ln/>
-        </p:spPr>
-        <p:txBody>
-          <a:bodyPr wrap="square" lIns="0" tIns="0" rIns="0" bIns="0" rtlCol="0" anchor="ctr"/>
-          <a:lstStyle/>
-          <a:p>
-            <a:pPr indent="0" marL="0">
-              <a:buNone/>
-            </a:pPr>
-            <a:r>
-              <a:rPr lang="en-US" sz="2500" b="1" dirty="0">
+            <a:endParaRPr lang="en-US" sz="5600" dirty="0"/>
+          </a:p>
+        </p:txBody>
+      </p:sp>
+      <p:sp>
+        <p:nvSpPr>
+          <p:cNvPr id="11" name="Text 9"/>
+          <p:cNvSpPr txBox="1"/>
+          <p:nvPr/>
+        </p:nvSpPr>
+        <p:spPr>
+          <a:xfrm>
+            <a:off x="1645920" y="4251960"/>
+            <a:ext cx="9875520" cy="548640"/>
+          </a:xfrm>
+          <a:prstGeom prst="rect">
+            <a:avLst/>
+          </a:prstGeom>
+          <a:noFill/>
+          <a:ln/>
+        </p:spPr>
+        <p:txBody>
+          <a:bodyPr wrap="square" lIns="0" tIns="0" rIns="0" bIns="0" rtlCol="0" anchor="ctr"/>
+          <a:lstStyle/>
+          <a:p>
+            <a:pPr indent="0" marL="0">
+              <a:buNone/>
+            </a:pPr>
+            <a:r>
+              <a:rPr lang="en-US" sz="2400" b="1" dirty="0">
                 <a:solidFill>
                   <a:srgbClr val="1A1712"/>
                 </a:solidFill>
@@ -3536,38 +3355,38 @@
               </a:rPr>
               <a:t>It plugs into any stream</a:t>
             </a:r>
-            <a:endParaRPr lang="en-US" sz="2500" dirty="0"/>
-          </a:p>
-        </p:txBody>
-      </p:sp>
-      <p:sp>
-        <p:nvSpPr>
-          <p:cNvPr id="13" name="Text 11"/>
-          <p:cNvSpPr txBox="1"/>
-          <p:nvPr/>
-        </p:nvSpPr>
-        <p:spPr>
-          <a:xfrm>
-            <a:off x="1600200" y="4910328"/>
-            <a:ext cx="9601200" cy="502920"/>
-          </a:xfrm>
-          <a:prstGeom prst="rect">
-            <a:avLst/>
-          </a:prstGeom>
-          <a:noFill/>
-          <a:ln/>
-        </p:spPr>
-        <p:txBody>
-          <a:bodyPr wrap="square" lIns="0" tIns="0" rIns="0" bIns="0" rtlCol="0" anchor="ctr"/>
-          <a:lstStyle/>
-          <a:p>
-            <a:pPr indent="0" marL="0">
-              <a:buNone/>
-            </a:pPr>
-            <a:r>
-              <a:rPr lang="en-US" sz="1700" dirty="0">
-                <a:solidFill>
-                  <a:srgbClr val="71685A"/>
+            <a:endParaRPr lang="en-US" sz="2400" dirty="0"/>
+          </a:p>
+        </p:txBody>
+      </p:sp>
+      <p:sp>
+        <p:nvSpPr>
+          <p:cNvPr id="12" name="Text 10"/>
+          <p:cNvSpPr txBox="1"/>
+          <p:nvPr/>
+        </p:nvSpPr>
+        <p:spPr>
+          <a:xfrm>
+            <a:off x="1645920" y="4800600"/>
+            <a:ext cx="9875520" cy="502920"/>
+          </a:xfrm>
+          <a:prstGeom prst="rect">
+            <a:avLst/>
+          </a:prstGeom>
+          <a:noFill/>
+          <a:ln/>
+        </p:spPr>
+        <p:txBody>
+          <a:bodyPr wrap="square" lIns="0" tIns="0" rIns="0" bIns="0" rtlCol="0" anchor="ctr"/>
+          <a:lstStyle/>
+          <a:p>
+            <a:pPr indent="0" marL="0">
+              <a:buNone/>
+            </a:pPr>
+            <a:r>
+              <a:rPr lang="en-US" sz="1600" dirty="0">
+                <a:solidFill>
+                  <a:srgbClr val="8A8274"/>
                 </a:solidFill>
                 <a:latin typeface="Georgia" pitchFamily="34" charset="0"/>
                 <a:ea typeface="Georgia" pitchFamily="34" charset="-122"/>
@@ -3575,61 +3394,38 @@
               </a:rPr>
               <a:t>Twitch · YouTube · Kick — plus an OBS overlay on the video itself</a:t>
             </a:r>
-            <a:endParaRPr lang="en-US" sz="1700" dirty="0"/>
-          </a:p>
-        </p:txBody>
-      </p:sp>
-      <p:sp>
-        <p:nvSpPr>
-          <p:cNvPr id="14" name="Shape 12"/>
-          <p:cNvSpPr/>
-          <p:nvPr/>
-        </p:nvSpPr>
-        <p:spPr>
-          <a:xfrm>
-            <a:off x="548640" y="5806440"/>
-            <a:ext cx="11091672" cy="0"/>
-          </a:xfrm>
-          <a:prstGeom prst="line">
-            <a:avLst/>
-          </a:prstGeom>
-          <a:noFill/>
-          <a:ln w="12700">
-            <a:solidFill>
-              <a:srgbClr val="D8CDB8"/>
-            </a:solidFill>
-            <a:prstDash val="solid"/>
-          </a:ln>
-        </p:spPr>
-      </p:sp>
-      <p:sp>
-        <p:nvSpPr>
-          <p:cNvPr id="15" name="Text 13"/>
-          <p:cNvSpPr txBox="1"/>
-          <p:nvPr/>
-        </p:nvSpPr>
-        <p:spPr>
-          <a:xfrm>
-            <a:off x="548640" y="5943600"/>
-            <a:ext cx="11064240" cy="457200"/>
-          </a:xfrm>
-          <a:prstGeom prst="rect">
-            <a:avLst/>
-          </a:prstGeom>
-          <a:noFill/>
-          <a:ln/>
-        </p:spPr>
-        <p:txBody>
-          <a:bodyPr wrap="square" lIns="0" tIns="0" rIns="0" bIns="0" rtlCol="0" anchor="ctr"/>
-          <a:lstStyle/>
-          <a:p>
-            <a:pPr indent="0" marL="0">
-              <a:buNone/>
-            </a:pPr>
-            <a:r>
-              <a:rPr lang="en-US" sz="1700" i="1" dirty="0">
-                <a:solidFill>
-                  <a:srgbClr val="71685A"/>
+            <a:endParaRPr lang="en-US" sz="1600" dirty="0"/>
+          </a:p>
+        </p:txBody>
+      </p:sp>
+      <p:sp>
+        <p:nvSpPr>
+          <p:cNvPr id="13" name="Text 11"/>
+          <p:cNvSpPr txBox="1"/>
+          <p:nvPr/>
+        </p:nvSpPr>
+        <p:spPr>
+          <a:xfrm>
+            <a:off x="640080" y="5897880"/>
+            <a:ext cx="10972800" cy="457200"/>
+          </a:xfrm>
+          <a:prstGeom prst="rect">
+            <a:avLst/>
+          </a:prstGeom>
+          <a:noFill/>
+          <a:ln/>
+        </p:spPr>
+        <p:txBody>
+          <a:bodyPr wrap="square" lIns="0" tIns="0" rIns="0" bIns="0" rtlCol="0" anchor="ctr"/>
+          <a:lstStyle/>
+          <a:p>
+            <a:pPr indent="0" marL="0">
+              <a:buNone/>
+            </a:pPr>
+            <a:r>
+              <a:rPr lang="en-US" sz="1600" i="1" dirty="0">
+                <a:solidFill>
+                  <a:srgbClr val="8A8274"/>
                 </a:solidFill>
                 <a:latin typeface="Georgia" pitchFamily="34" charset="0"/>
                 <a:ea typeface="Georgia" pitchFamily="34" charset="-122"/>
@@ -3637,7 +3433,7 @@
               </a:rPr>
               <a:t>The streamer sets the price of a word. Spam gets expensive; attention gets honestly paid for.</a:t>
             </a:r>
-            <a:endParaRPr lang="en-US" sz="1700" dirty="0"/>
+            <a:endParaRPr lang="en-US" sz="1600" dirty="0"/>
           </a:p>
         </p:txBody>
       </p:sp>
@@ -3681,26 +3477,26 @@
         </p:nvSpPr>
         <p:spPr>
           <a:xfrm>
-            <a:off x="548640" y="411480"/>
-            <a:ext cx="10424160" cy="502920"/>
-          </a:xfrm>
-          <a:prstGeom prst="rect">
-            <a:avLst/>
-          </a:prstGeom>
-          <a:noFill/>
-          <a:ln/>
-        </p:spPr>
-        <p:txBody>
-          <a:bodyPr wrap="square" lIns="0" tIns="0" rIns="0" bIns="0" rtlCol="0" anchor="ctr"/>
-          <a:lstStyle/>
-          <a:p>
-            <a:pPr indent="0" marL="0">
-              <a:buNone/>
-            </a:pPr>
-            <a:r>
-              <a:rPr lang="en-US" sz="1600" b="1" spc="300" kern="0" dirty="0">
-                <a:solidFill>
-                  <a:srgbClr val="1A1712"/>
+            <a:off x="640080" y="457200"/>
+            <a:ext cx="10058400" cy="365760"/>
+          </a:xfrm>
+          <a:prstGeom prst="rect">
+            <a:avLst/>
+          </a:prstGeom>
+          <a:noFill/>
+          <a:ln/>
+        </p:spPr>
+        <p:txBody>
+          <a:bodyPr wrap="square" lIns="0" tIns="0" rIns="0" bIns="0" rtlCol="0" anchor="ctr"/>
+          <a:lstStyle/>
+          <a:p>
+            <a:pPr indent="0" marL="0">
+              <a:buNone/>
+            </a:pPr>
+            <a:r>
+              <a:rPr lang="en-US" sz="1200" b="1" spc="300" kern="0" dirty="0">
+                <a:solidFill>
+                  <a:srgbClr val="8A8274"/>
                 </a:solidFill>
                 <a:latin typeface="Courier New" pitchFamily="34" charset="0"/>
                 <a:ea typeface="Courier New" pitchFamily="34" charset="-122"/>
@@ -3708,7 +3504,7 @@
               </a:rPr>
               <a:t>LIVE TODAY — NOT A CONCEPT</a:t>
             </a:r>
-            <a:endParaRPr lang="en-US" sz="1600" dirty="0"/>
+            <a:endParaRPr lang="en-US" sz="1200" dirty="0"/>
           </a:p>
         </p:txBody>
       </p:sp>
@@ -3720,8 +3516,8 @@
         </p:nvSpPr>
         <p:spPr>
           <a:xfrm>
-            <a:off x="11137392" y="411480"/>
-            <a:ext cx="502920" cy="502920"/>
+            <a:off x="11045952" y="457200"/>
+            <a:ext cx="502920" cy="365760"/>
           </a:xfrm>
           <a:prstGeom prst="rect">
             <a:avLst/>
@@ -3737,9 +3533,9 @@
               <a:buNone/>
             </a:pPr>
             <a:r>
-              <a:rPr lang="en-US" sz="1600" dirty="0">
-                <a:solidFill>
-                  <a:srgbClr val="71685A"/>
+              <a:rPr lang="en-US" sz="1200" dirty="0">
+                <a:solidFill>
+                  <a:srgbClr val="8A8274"/>
                 </a:solidFill>
                 <a:latin typeface="Courier New" pitchFamily="34" charset="0"/>
                 <a:ea typeface="Courier New" pitchFamily="34" charset="-122"/>
@@ -3747,92 +3543,97 @@
               </a:rPr>
               <a:t>06</a:t>
             </a:r>
-            <a:endParaRPr lang="en-US" sz="1600" dirty="0"/>
-          </a:p>
-        </p:txBody>
-      </p:sp>
-      <p:sp>
-        <p:nvSpPr>
-          <p:cNvPr id="4" name="Shape 2"/>
-          <p:cNvSpPr/>
-          <p:nvPr/>
-        </p:nvSpPr>
-        <p:spPr>
-          <a:xfrm>
-            <a:off x="548640" y="960120"/>
-            <a:ext cx="11091672" cy="0"/>
-          </a:xfrm>
-          <a:prstGeom prst="line">
-            <a:avLst/>
-          </a:prstGeom>
-          <a:noFill/>
-          <a:ln w="15240">
-            <a:solidFill>
-              <a:srgbClr val="1A1712"/>
-            </a:solidFill>
-            <a:prstDash val="solid"/>
-          </a:ln>
-        </p:spPr>
-      </p:sp>
-      <p:sp>
-        <p:nvSpPr>
-          <p:cNvPr id="5" name="Shape 3"/>
-          <p:cNvSpPr/>
-          <p:nvPr/>
-        </p:nvSpPr>
-        <p:spPr>
-          <a:xfrm>
-            <a:off x="548640" y="1325880"/>
-            <a:ext cx="6400800" cy="4114800"/>
-          </a:xfrm>
-          <a:prstGeom prst="rect">
-            <a:avLst/>
-          </a:prstGeom>
-          <a:solidFill>
-            <a:srgbClr val="ECE4D3"/>
-          </a:solidFill>
-          <a:ln w="15240">
-            <a:solidFill>
-              <a:srgbClr val="1A1712"/>
-            </a:solidFill>
-            <a:prstDash val="solid"/>
-          </a:ln>
-        </p:spPr>
-      </p:sp>
-      <p:sp>
-        <p:nvSpPr>
-          <p:cNvPr id="6" name="Text 4"/>
-          <p:cNvSpPr txBox="1"/>
-          <p:nvPr/>
-        </p:nvSpPr>
-        <p:spPr>
-          <a:xfrm>
-            <a:off x="868680" y="1554480"/>
-            <a:ext cx="1097280" cy="320040"/>
-          </a:xfrm>
-          <a:prstGeom prst="rect">
-            <a:avLst/>
-          </a:prstGeom>
-          <a:noFill/>
-          <a:ln/>
-        </p:spPr>
-        <p:txBody>
-          <a:bodyPr wrap="square" lIns="0" tIns="0" rIns="0" bIns="0" rtlCol="0" anchor="ctr"/>
-          <a:lstStyle/>
-          <a:p>
-            <a:pPr indent="0" marL="0">
-              <a:buNone/>
-            </a:pPr>
-            <a:r>
-              <a:rPr lang="en-US" sz="1200" b="1" spc="300" kern="0" dirty="0">
+            <a:endParaRPr lang="en-US" sz="1200" dirty="0"/>
+          </a:p>
+        </p:txBody>
+      </p:sp>
+      <p:sp>
+        <p:nvSpPr>
+          <p:cNvPr id="4" name="Text 2"/>
+          <p:cNvSpPr txBox="1"/>
+          <p:nvPr/>
+        </p:nvSpPr>
+        <p:spPr>
+          <a:xfrm>
+            <a:off x="640080" y="1554480"/>
+            <a:ext cx="5852160" cy="457200"/>
+          </a:xfrm>
+          <a:prstGeom prst="rect">
+            <a:avLst/>
+          </a:prstGeom>
+          <a:noFill/>
+          <a:ln/>
+        </p:spPr>
+        <p:txBody>
+          <a:bodyPr wrap="square" lIns="0" tIns="0" rIns="0" bIns="0" rtlCol="0" anchor="ctr"/>
+          <a:lstStyle/>
+          <a:p>
+            <a:pPr indent="0" marL="0">
+              <a:buNone/>
+            </a:pPr>
+            <a:r>
+              <a:rPr lang="en-US" sz="1800" b="1" dirty="0">
+                <a:solidFill>
+                  <a:srgbClr val="BF3A1E"/>
+                </a:solidFill>
+                <a:latin typeface="Georgia" pitchFamily="34" charset="0"/>
+                <a:ea typeface="Georgia" pitchFamily="34" charset="-122"/>
+                <a:cs typeface="Georgia" pitchFamily="34" charset="-120"/>
+              </a:rPr>
+              <a:t>mona</a:t>
+            </a:r>
+            <a:pPr indent="0" marL="0">
+              <a:buNone/>
+            </a:pPr>
+            <a:r>
+              <a:rPr lang="en-US" sz="1800" dirty="0">
                 <a:solidFill>
                   <a:srgbClr val="1A1712"/>
+                </a:solidFill>
+                <a:latin typeface="Georgia" pitchFamily="34" charset="0"/>
+                <a:ea typeface="Georgia" pitchFamily="34" charset="-122"/>
+                <a:cs typeface="Georgia" pitchFamily="34" charset="-120"/>
+              </a:rPr>
+              <a:t>  ·  gm Amsterdam — this line cost money</a:t>
+            </a:r>
+            <a:endParaRPr lang="en-US" sz="1800" dirty="0"/>
+          </a:p>
+        </p:txBody>
+      </p:sp>
+      <p:sp>
+        <p:nvSpPr>
+          <p:cNvPr id="5" name="Text 3"/>
+          <p:cNvSpPr txBox="1"/>
+          <p:nvPr/>
+        </p:nvSpPr>
+        <p:spPr>
+          <a:xfrm>
+            <a:off x="640080" y="2011680"/>
+            <a:ext cx="5577840" cy="365760"/>
+          </a:xfrm>
+          <a:prstGeom prst="rect">
+            <a:avLst/>
+          </a:prstGeom>
+          <a:noFill/>
+          <a:ln/>
+        </p:spPr>
+        <p:txBody>
+          <a:bodyPr wrap="square" lIns="0" tIns="0" rIns="0" bIns="0" rtlCol="0" anchor="ctr"/>
+          <a:lstStyle/>
+          <a:p>
+            <a:pPr indent="0" marL="0">
+              <a:buNone/>
+            </a:pPr>
+            <a:r>
+              <a:rPr lang="en-US" sz="1200" b="1" dirty="0">
+                <a:solidFill>
+                  <a:srgbClr val="1C6B4A"/>
                 </a:solidFill>
                 <a:latin typeface="Courier New" pitchFamily="34" charset="0"/>
                 <a:ea typeface="Courier New" pitchFamily="34" charset="-122"/>
                 <a:cs typeface="Courier New" pitchFamily="34" charset="-120"/>
               </a:rPr>
-              <a:t>CHAT</a:t>
+              <a:t>0.05</a:t>
             </a:r>
             <a:endParaRPr lang="en-US" sz="1200" dirty="0"/>
           </a:p>
@@ -3840,87 +3641,44 @@
       </p:sp>
       <p:sp>
         <p:nvSpPr>
-          <p:cNvPr id="7" name="Shape 5"/>
-          <p:cNvSpPr/>
-          <p:nvPr/>
-        </p:nvSpPr>
-        <p:spPr>
-          <a:xfrm>
-            <a:off x="1645920" y="1664208"/>
-            <a:ext cx="91440" cy="91440"/>
-          </a:xfrm>
-          <a:prstGeom prst="ellipse">
-            <a:avLst/>
-          </a:prstGeom>
-          <a:solidFill>
-            <a:srgbClr val="1C6B4A"/>
-          </a:solidFill>
-          <a:ln/>
-        </p:spPr>
-      </p:sp>
-      <p:sp>
-        <p:nvSpPr>
-          <p:cNvPr id="8" name="Shape 6"/>
-          <p:cNvSpPr/>
-          <p:nvPr/>
-        </p:nvSpPr>
-        <p:spPr>
-          <a:xfrm>
-            <a:off x="548640" y="1993392"/>
-            <a:ext cx="6400800" cy="0"/>
-          </a:xfrm>
-          <a:prstGeom prst="line">
-            <a:avLst/>
-          </a:prstGeom>
-          <a:noFill/>
-          <a:ln w="12700">
-            <a:solidFill>
-              <a:srgbClr val="1A1712"/>
-            </a:solidFill>
-            <a:prstDash val="solid"/>
-          </a:ln>
-        </p:spPr>
-      </p:sp>
-      <p:sp>
-        <p:nvSpPr>
-          <p:cNvPr id="9" name="Text 7"/>
-          <p:cNvSpPr txBox="1"/>
-          <p:nvPr/>
-        </p:nvSpPr>
-        <p:spPr>
-          <a:xfrm>
-            <a:off x="868680" y="2286000"/>
-            <a:ext cx="5760720" cy="457200"/>
-          </a:xfrm>
-          <a:prstGeom prst="rect">
-            <a:avLst/>
-          </a:prstGeom>
-          <a:noFill/>
-          <a:ln/>
-        </p:spPr>
-        <p:txBody>
-          <a:bodyPr wrap="square" lIns="0" tIns="0" rIns="0" bIns="0" rtlCol="0" anchor="ctr"/>
-          <a:lstStyle/>
-          <a:p>
-            <a:pPr indent="0" marL="0">
-              <a:buNone/>
-            </a:pPr>
-            <a:r>
-              <a:rPr lang="en-US" sz="1700" b="1" dirty="0">
-                <a:solidFill>
-                  <a:srgbClr val="BF3A1E"/>
+          <p:cNvPr id="6" name="Text 4"/>
+          <p:cNvSpPr txBox="1"/>
+          <p:nvPr/>
+        </p:nvSpPr>
+        <p:spPr>
+          <a:xfrm>
+            <a:off x="640080" y="2606040"/>
+            <a:ext cx="5852160" cy="457200"/>
+          </a:xfrm>
+          <a:prstGeom prst="rect">
+            <a:avLst/>
+          </a:prstGeom>
+          <a:noFill/>
+          <a:ln/>
+        </p:spPr>
+        <p:txBody>
+          <a:bodyPr wrap="square" lIns="0" tIns="0" rIns="0" bIns="0" rtlCol="0" anchor="ctr"/>
+          <a:lstStyle/>
+          <a:p>
+            <a:pPr indent="0" marL="0">
+              <a:buNone/>
+            </a:pPr>
+            <a:r>
+              <a:rPr lang="en-US" sz="1800" b="1" dirty="0">
+                <a:solidFill>
+                  <a:srgbClr val="1C6B4A"/>
                 </a:solidFill>
                 <a:latin typeface="Georgia" pitchFamily="34" charset="0"/>
                 <a:ea typeface="Georgia" pitchFamily="34" charset="-122"/>
                 <a:cs typeface="Georgia" pitchFamily="34" charset="-120"/>
               </a:rPr>
-              <a:t>mona</a:t>
-            </a:r>
-            <a:pPr indent="0" marL="0">
-              <a:buNone/>
-            </a:pPr>
-            <a:r>
-              <a:rPr lang="en-US" sz="1700" dirty="0">
+              <a:t>nad_holder</a:t>
+            </a:r>
+            <a:pPr indent="0" marL="0">
+              <a:buNone/>
+            </a:pPr>
+            <a:r>
+              <a:rPr lang="en-US" sz="1800" dirty="0">
                 <a:solidFill>
                   <a:srgbClr val="1A1712"/>
                 </a:solidFill>
@@ -3928,61 +3686,38 @@
                 <a:ea typeface="Georgia" pitchFamily="34" charset="-122"/>
                 <a:cs typeface="Georgia" pitchFamily="34" charset="-120"/>
               </a:rPr>
-              <a:t>  ·  gm Amsterdam — this line cost money</a:t>
-            </a:r>
-            <a:endParaRPr lang="en-US" sz="1700" dirty="0"/>
-          </a:p>
-        </p:txBody>
-      </p:sp>
-      <p:sp>
-        <p:nvSpPr>
-          <p:cNvPr id="10" name="Shape 8"/>
-          <p:cNvSpPr/>
-          <p:nvPr/>
-        </p:nvSpPr>
-        <p:spPr>
-          <a:xfrm>
-            <a:off x="868680" y="2889504"/>
-            <a:ext cx="4206240" cy="0"/>
-          </a:xfrm>
-          <a:prstGeom prst="line">
-            <a:avLst/>
-          </a:prstGeom>
-          <a:noFill/>
-          <a:ln w="12700">
-            <a:solidFill>
-              <a:srgbClr val="71685A"/>
-            </a:solidFill>
-            <a:prstDash val="sysDot"/>
-          </a:ln>
-        </p:spPr>
-      </p:sp>
-      <p:sp>
-        <p:nvSpPr>
-          <p:cNvPr id="11" name="Text 9"/>
-          <p:cNvSpPr txBox="1"/>
-          <p:nvPr/>
-        </p:nvSpPr>
-        <p:spPr>
-          <a:xfrm>
-            <a:off x="4754880" y="2688336"/>
-            <a:ext cx="1828800" cy="365760"/>
-          </a:xfrm>
-          <a:prstGeom prst="rect">
-            <a:avLst/>
-          </a:prstGeom>
-          <a:noFill/>
-          <a:ln/>
-        </p:spPr>
-        <p:txBody>
-          <a:bodyPr wrap="square" lIns="0" tIns="0" rIns="0" bIns="0" rtlCol="0" anchor="ctr"/>
-          <a:lstStyle/>
-          <a:p>
-            <a:pPr algn="r" indent="0" marL="0">
-              <a:buNone/>
-            </a:pPr>
-            <a:r>
-              <a:rPr lang="en-US" sz="1300" b="1" dirty="0">
+              <a:t>  ·  every message here is a transaction</a:t>
+            </a:r>
+            <a:endParaRPr lang="en-US" sz="1800" dirty="0"/>
+          </a:p>
+        </p:txBody>
+      </p:sp>
+      <p:sp>
+        <p:nvSpPr>
+          <p:cNvPr id="7" name="Text 5"/>
+          <p:cNvSpPr txBox="1"/>
+          <p:nvPr/>
+        </p:nvSpPr>
+        <p:spPr>
+          <a:xfrm>
+            <a:off x="640080" y="3063240"/>
+            <a:ext cx="5577840" cy="365760"/>
+          </a:xfrm>
+          <a:prstGeom prst="rect">
+            <a:avLst/>
+          </a:prstGeom>
+          <a:noFill/>
+          <a:ln/>
+        </p:spPr>
+        <p:txBody>
+          <a:bodyPr wrap="square" lIns="0" tIns="0" rIns="0" bIns="0" rtlCol="0" anchor="ctr"/>
+          <a:lstStyle/>
+          <a:p>
+            <a:pPr indent="0" marL="0">
+              <a:buNone/>
+            </a:pPr>
+            <a:r>
+              <a:rPr lang="en-US" sz="1200" b="1" dirty="0">
                 <a:solidFill>
                   <a:srgbClr val="1C6B4A"/>
                 </a:solidFill>
@@ -3992,50 +3727,50 @@
               </a:rPr>
               <a:t>0.05</a:t>
             </a:r>
-            <a:endParaRPr lang="en-US" sz="1300" dirty="0"/>
-          </a:p>
-        </p:txBody>
-      </p:sp>
-      <p:sp>
-        <p:nvSpPr>
-          <p:cNvPr id="12" name="Text 10"/>
-          <p:cNvSpPr txBox="1"/>
-          <p:nvPr/>
-        </p:nvSpPr>
-        <p:spPr>
-          <a:xfrm>
-            <a:off x="868680" y="3291840"/>
-            <a:ext cx="5760720" cy="457200"/>
-          </a:xfrm>
-          <a:prstGeom prst="rect">
-            <a:avLst/>
-          </a:prstGeom>
-          <a:noFill/>
-          <a:ln/>
-        </p:spPr>
-        <p:txBody>
-          <a:bodyPr wrap="square" lIns="0" tIns="0" rIns="0" bIns="0" rtlCol="0" anchor="ctr"/>
-          <a:lstStyle/>
-          <a:p>
-            <a:pPr indent="0" marL="0">
-              <a:buNone/>
-            </a:pPr>
-            <a:r>
-              <a:rPr lang="en-US" sz="1700" b="1" dirty="0">
-                <a:solidFill>
-                  <a:srgbClr val="1C6B4A"/>
+            <a:endParaRPr lang="en-US" sz="1200" dirty="0"/>
+          </a:p>
+        </p:txBody>
+      </p:sp>
+      <p:sp>
+        <p:nvSpPr>
+          <p:cNvPr id="8" name="Text 6"/>
+          <p:cNvSpPr txBox="1"/>
+          <p:nvPr/>
+        </p:nvSpPr>
+        <p:spPr>
+          <a:xfrm>
+            <a:off x="640080" y="3657600"/>
+            <a:ext cx="5852160" cy="457200"/>
+          </a:xfrm>
+          <a:prstGeom prst="rect">
+            <a:avLst/>
+          </a:prstGeom>
+          <a:noFill/>
+          <a:ln/>
+        </p:spPr>
+        <p:txBody>
+          <a:bodyPr wrap="square" lIns="0" tIns="0" rIns="0" bIns="0" rtlCol="0" anchor="ctr"/>
+          <a:lstStyle/>
+          <a:p>
+            <a:pPr indent="0" marL="0">
+              <a:buNone/>
+            </a:pPr>
+            <a:r>
+              <a:rPr lang="en-US" sz="1800" b="1" dirty="0">
+                <a:solidFill>
+                  <a:srgbClr val="1D5A8A"/>
                 </a:solidFill>
                 <a:latin typeface="Georgia" pitchFamily="34" charset="0"/>
                 <a:ea typeface="Georgia" pitchFamily="34" charset="-122"/>
                 <a:cs typeface="Georgia" pitchFamily="34" charset="-120"/>
               </a:rPr>
-              <a:t>nad_holder</a:t>
-            </a:r>
-            <a:pPr indent="0" marL="0">
-              <a:buNone/>
-            </a:pPr>
-            <a:r>
-              <a:rPr lang="en-US" sz="1700" dirty="0">
+              <a:t>blitz_fan</a:t>
+            </a:r>
+            <a:pPr indent="0" marL="0">
+              <a:buNone/>
+            </a:pPr>
+            <a:r>
+              <a:rPr lang="en-US" sz="1800" dirty="0">
                 <a:solidFill>
                   <a:srgbClr val="1A1712"/>
                 </a:solidFill>
@@ -4043,61 +3778,38 @@
                 <a:ea typeface="Georgia" pitchFamily="34" charset="-122"/>
                 <a:cs typeface="Georgia" pitchFamily="34" charset="-120"/>
               </a:rPr>
-              <a:t>  ·  every message here is a transaction</a:t>
-            </a:r>
-            <a:endParaRPr lang="en-US" sz="1700" dirty="0"/>
-          </a:p>
-        </p:txBody>
-      </p:sp>
-      <p:sp>
-        <p:nvSpPr>
-          <p:cNvPr id="13" name="Shape 11"/>
-          <p:cNvSpPr/>
-          <p:nvPr/>
-        </p:nvSpPr>
-        <p:spPr>
-          <a:xfrm>
-            <a:off x="868680" y="3895344"/>
-            <a:ext cx="4206240" cy="0"/>
-          </a:xfrm>
-          <a:prstGeom prst="line">
-            <a:avLst/>
-          </a:prstGeom>
-          <a:noFill/>
-          <a:ln w="12700">
-            <a:solidFill>
-              <a:srgbClr val="71685A"/>
-            </a:solidFill>
-            <a:prstDash val="sysDot"/>
-          </a:ln>
-        </p:spPr>
-      </p:sp>
-      <p:sp>
-        <p:nvSpPr>
-          <p:cNvPr id="14" name="Text 12"/>
-          <p:cNvSpPr txBox="1"/>
-          <p:nvPr/>
-        </p:nvSpPr>
-        <p:spPr>
-          <a:xfrm>
-            <a:off x="4754880" y="3694176"/>
-            <a:ext cx="1828800" cy="365760"/>
-          </a:xfrm>
-          <a:prstGeom prst="rect">
-            <a:avLst/>
-          </a:prstGeom>
-          <a:noFill/>
-          <a:ln/>
-        </p:spPr>
-        <p:txBody>
-          <a:bodyPr wrap="square" lIns="0" tIns="0" rIns="0" bIns="0" rtlCol="0" anchor="ctr"/>
-          <a:lstStyle/>
-          <a:p>
-            <a:pPr algn="r" indent="0" marL="0">
-              <a:buNone/>
-            </a:pPr>
-            <a:r>
-              <a:rPr lang="en-US" sz="1300" b="1" dirty="0">
+              <a:t>  ·  watch the badge → half a second</a:t>
+            </a:r>
+            <a:endParaRPr lang="en-US" sz="1800" dirty="0"/>
+          </a:p>
+        </p:txBody>
+      </p:sp>
+      <p:sp>
+        <p:nvSpPr>
+          <p:cNvPr id="9" name="Text 7"/>
+          <p:cNvSpPr txBox="1"/>
+          <p:nvPr/>
+        </p:nvSpPr>
+        <p:spPr>
+          <a:xfrm>
+            <a:off x="640080" y="4114800"/>
+            <a:ext cx="5577840" cy="365760"/>
+          </a:xfrm>
+          <a:prstGeom prst="rect">
+            <a:avLst/>
+          </a:prstGeom>
+          <a:noFill/>
+          <a:ln/>
+        </p:spPr>
+        <p:txBody>
+          <a:bodyPr wrap="square" lIns="0" tIns="0" rIns="0" bIns="0" rtlCol="0" anchor="ctr"/>
+          <a:lstStyle/>
+          <a:p>
+            <a:pPr indent="0" marL="0">
+              <a:buNone/>
+            </a:pPr>
+            <a:r>
+              <a:rPr lang="en-US" sz="1200" b="1" dirty="0">
                 <a:solidFill>
                   <a:srgbClr val="1C6B4A"/>
                 </a:solidFill>
@@ -4105,52 +3817,77 @@
                 <a:ea typeface="Courier New" pitchFamily="34" charset="-122"/>
                 <a:cs typeface="Courier New" pitchFamily="34" charset="-120"/>
               </a:rPr>
-              <a:t>0.05</a:t>
-            </a:r>
-            <a:endParaRPr lang="en-US" sz="1300" dirty="0"/>
-          </a:p>
-        </p:txBody>
-      </p:sp>
-      <p:sp>
-        <p:nvSpPr>
-          <p:cNvPr id="15" name="Text 13"/>
-          <p:cNvSpPr txBox="1"/>
-          <p:nvPr/>
-        </p:nvSpPr>
-        <p:spPr>
-          <a:xfrm>
-            <a:off x="868680" y="4297680"/>
-            <a:ext cx="5760720" cy="457200"/>
-          </a:xfrm>
-          <a:prstGeom prst="rect">
-            <a:avLst/>
-          </a:prstGeom>
-          <a:noFill/>
-          <a:ln/>
-        </p:spPr>
-        <p:txBody>
-          <a:bodyPr wrap="square" lIns="0" tIns="0" rIns="0" bIns="0" rtlCol="0" anchor="ctr"/>
-          <a:lstStyle/>
-          <a:p>
-            <a:pPr indent="0" marL="0">
-              <a:buNone/>
-            </a:pPr>
-            <a:r>
-              <a:rPr lang="en-US" sz="1700" b="1" dirty="0">
-                <a:solidFill>
-                  <a:srgbClr val="1D5A8A"/>
+              <a:t>0.05 · 0.55s</a:t>
+            </a:r>
+            <a:endParaRPr lang="en-US" sz="1200" dirty="0"/>
+          </a:p>
+        </p:txBody>
+      </p:sp>
+      <p:sp>
+        <p:nvSpPr>
+          <p:cNvPr id="10" name="Text 8"/>
+          <p:cNvSpPr txBox="1"/>
+          <p:nvPr/>
+        </p:nvSpPr>
+        <p:spPr>
+          <a:xfrm>
+            <a:off x="6949440" y="1554480"/>
+            <a:ext cx="4663440" cy="548640"/>
+          </a:xfrm>
+          <a:prstGeom prst="rect">
+            <a:avLst/>
+          </a:prstGeom>
+          <a:noFill/>
+          <a:ln/>
+        </p:spPr>
+        <p:txBody>
+          <a:bodyPr wrap="square" lIns="0" tIns="0" rIns="0" bIns="0" rtlCol="0" anchor="ctr"/>
+          <a:lstStyle/>
+          <a:p>
+            <a:pPr indent="0" marL="0">
+              <a:buNone/>
+            </a:pPr>
+            <a:r>
+              <a:rPr lang="en-US" sz="1800" dirty="0">
+                <a:solidFill>
+                  <a:srgbClr val="1A1712"/>
                 </a:solidFill>
                 <a:latin typeface="Georgia" pitchFamily="34" charset="0"/>
                 <a:ea typeface="Georgia" pitchFamily="34" charset="-122"/>
                 <a:cs typeface="Georgia" pitchFamily="34" charset="-120"/>
               </a:rPr>
-              <a:t>blitz_fan</a:t>
-            </a:r>
-            <a:pPr indent="0" marL="0">
-              <a:buNone/>
-            </a:pPr>
-            <a:r>
-              <a:rPr lang="en-US" sz="1700" dirty="0">
+              <a:t>— real rooms, real MON moving today</a:t>
+            </a:r>
+            <a:endParaRPr lang="en-US" sz="1800" dirty="0"/>
+          </a:p>
+        </p:txBody>
+      </p:sp>
+      <p:sp>
+        <p:nvSpPr>
+          <p:cNvPr id="11" name="Text 9"/>
+          <p:cNvSpPr txBox="1"/>
+          <p:nvPr/>
+        </p:nvSpPr>
+        <p:spPr>
+          <a:xfrm>
+            <a:off x="6949440" y="2331720"/>
+            <a:ext cx="4663440" cy="548640"/>
+          </a:xfrm>
+          <a:prstGeom prst="rect">
+            <a:avLst/>
+          </a:prstGeom>
+          <a:noFill/>
+          <a:ln/>
+        </p:spPr>
+        <p:txBody>
+          <a:bodyPr wrap="square" lIns="0" tIns="0" rIns="0" bIns="0" rtlCol="0" anchor="ctr"/>
+          <a:lstStyle/>
+          <a:p>
+            <a:pPr indent="0" marL="0">
+              <a:buNone/>
+            </a:pPr>
+            <a:r>
+              <a:rPr lang="en-US" sz="1800" dirty="0">
                 <a:solidFill>
                   <a:srgbClr val="1A1712"/>
                 </a:solidFill>
@@ -4158,346 +3895,126 @@
                 <a:ea typeface="Georgia" pitchFamily="34" charset="-122"/>
                 <a:cs typeface="Georgia" pitchFamily="34" charset="-120"/>
               </a:rPr>
-              <a:t>  ·  watch the badge → half a second</a:t>
-            </a:r>
-            <a:endParaRPr lang="en-US" sz="1700" dirty="0"/>
-          </a:p>
-        </p:txBody>
-      </p:sp>
-      <p:sp>
-        <p:nvSpPr>
-          <p:cNvPr id="16" name="Shape 14"/>
-          <p:cNvSpPr/>
-          <p:nvPr/>
-        </p:nvSpPr>
-        <p:spPr>
-          <a:xfrm>
-            <a:off x="868680" y="4901184"/>
-            <a:ext cx="4206240" cy="0"/>
-          </a:xfrm>
-          <a:prstGeom prst="line">
-            <a:avLst/>
-          </a:prstGeom>
-          <a:noFill/>
-          <a:ln w="12700">
-            <a:solidFill>
-              <a:srgbClr val="71685A"/>
-            </a:solidFill>
-            <a:prstDash val="sysDot"/>
-          </a:ln>
-        </p:spPr>
-      </p:sp>
-      <p:sp>
-        <p:nvSpPr>
-          <p:cNvPr id="17" name="Text 15"/>
-          <p:cNvSpPr txBox="1"/>
-          <p:nvPr/>
-        </p:nvSpPr>
-        <p:spPr>
-          <a:xfrm>
-            <a:off x="4754880" y="4700016"/>
-            <a:ext cx="1828800" cy="365760"/>
-          </a:xfrm>
-          <a:prstGeom prst="rect">
-            <a:avLst/>
-          </a:prstGeom>
-          <a:noFill/>
-          <a:ln/>
-        </p:spPr>
-        <p:txBody>
-          <a:bodyPr wrap="square" lIns="0" tIns="0" rIns="0" bIns="0" rtlCol="0" anchor="ctr"/>
-          <a:lstStyle/>
-          <a:p>
-            <a:pPr algn="r" indent="0" marL="0">
+              <a:t>— latency printed on every message</a:t>
+            </a:r>
+            <a:endParaRPr lang="en-US" sz="1800" dirty="0"/>
+          </a:p>
+        </p:txBody>
+      </p:sp>
+      <p:sp>
+        <p:nvSpPr>
+          <p:cNvPr id="12" name="Text 10"/>
+          <p:cNvSpPr txBox="1"/>
+          <p:nvPr/>
+        </p:nvSpPr>
+        <p:spPr>
+          <a:xfrm>
+            <a:off x="6949440" y="3108960"/>
+            <a:ext cx="4663440" cy="548640"/>
+          </a:xfrm>
+          <a:prstGeom prst="rect">
+            <a:avLst/>
+          </a:prstGeom>
+          <a:noFill/>
+          <a:ln/>
+        </p:spPr>
+        <p:txBody>
+          <a:bodyPr wrap="square" lIns="0" tIns="0" rIns="0" bIns="0" rtlCol="0" anchor="ctr"/>
+          <a:lstStyle/>
+          <a:p>
+            <a:pPr indent="0" marL="0">
+              <a:buNone/>
+            </a:pPr>
+            <a:r>
+              <a:rPr lang="en-US" sz="1800" dirty="0">
+                <a:solidFill>
+                  <a:srgbClr val="1A1712"/>
+                </a:solidFill>
+                <a:latin typeface="Georgia" pitchFamily="34" charset="0"/>
+                <a:ea typeface="Georgia" pitchFamily="34" charset="-122"/>
+                <a:cs typeface="Georgia" pitchFamily="34" charset="-120"/>
+              </a:rPr>
+              <a:t>— a 67-line contract — verified</a:t>
+            </a:r>
+            <a:endParaRPr lang="en-US" sz="1800" dirty="0"/>
+          </a:p>
+        </p:txBody>
+      </p:sp>
+      <p:sp>
+        <p:nvSpPr>
+          <p:cNvPr id="13" name="Text 11"/>
+          <p:cNvSpPr txBox="1"/>
+          <p:nvPr/>
+        </p:nvSpPr>
+        <p:spPr>
+          <a:xfrm>
+            <a:off x="6949440" y="3886200"/>
+            <a:ext cx="4663440" cy="548640"/>
+          </a:xfrm>
+          <a:prstGeom prst="rect">
+            <a:avLst/>
+          </a:prstGeom>
+          <a:noFill/>
+          <a:ln/>
+        </p:spPr>
+        <p:txBody>
+          <a:bodyPr wrap="square" lIns="0" tIns="0" rIns="0" bIns="0" rtlCol="0" anchor="ctr"/>
+          <a:lstStyle/>
+          <a:p>
+            <a:pPr indent="0" marL="0">
+              <a:buNone/>
+            </a:pPr>
+            <a:r>
+              <a:rPr lang="en-US" sz="1800" dirty="0">
+                <a:solidFill>
+                  <a:srgbClr val="1A1712"/>
+                </a:solidFill>
+                <a:latin typeface="Georgia" pitchFamily="34" charset="0"/>
+                <a:ea typeface="Georgia" pitchFamily="34" charset="-122"/>
+                <a:cs typeface="Georgia" pitchFamily="34" charset="-120"/>
+              </a:rPr>
+              <a:t>— zero servers: the chain is the backend</a:t>
+            </a:r>
+            <a:endParaRPr lang="en-US" sz="1800" dirty="0"/>
+          </a:p>
+        </p:txBody>
+      </p:sp>
+      <p:sp>
+        <p:nvSpPr>
+          <p:cNvPr id="14" name="Text 12"/>
+          <p:cNvSpPr txBox="1"/>
+          <p:nvPr/>
+        </p:nvSpPr>
+        <p:spPr>
+          <a:xfrm>
+            <a:off x="6949440" y="4846320"/>
+            <a:ext cx="4663440" cy="457200"/>
+          </a:xfrm>
+          <a:prstGeom prst="rect">
+            <a:avLst/>
+          </a:prstGeom>
+          <a:noFill/>
+          <a:ln/>
+        </p:spPr>
+        <p:txBody>
+          <a:bodyPr wrap="square" lIns="0" tIns="0" rIns="0" bIns="0" rtlCol="0" anchor="ctr"/>
+          <a:lstStyle/>
+          <a:p>
+            <a:pPr indent="0" marL="0">
               <a:buNone/>
             </a:pPr>
             <a:r>
               <a:rPr lang="en-US" sz="1300" b="1" dirty="0">
                 <a:solidFill>
-                  <a:srgbClr val="1C6B4A"/>
+                  <a:srgbClr val="BF3A1E"/>
                 </a:solidFill>
                 <a:latin typeface="Courier New" pitchFamily="34" charset="0"/>
                 <a:ea typeface="Courier New" pitchFamily="34" charset="-122"/>
                 <a:cs typeface="Courier New" pitchFamily="34" charset="-120"/>
               </a:rPr>
-              <a:t>0.05 · 0.55s</a:t>
+              <a:t>try it from your phone right now</a:t>
             </a:r>
             <a:endParaRPr lang="en-US" sz="1300" dirty="0"/>
-          </a:p>
-        </p:txBody>
-      </p:sp>
-      <p:sp>
-        <p:nvSpPr>
-          <p:cNvPr id="18" name="Shape 16"/>
-          <p:cNvSpPr/>
-          <p:nvPr/>
-        </p:nvSpPr>
-        <p:spPr>
-          <a:xfrm>
-            <a:off x="7315200" y="1664208"/>
-            <a:ext cx="146304" cy="146304"/>
-          </a:xfrm>
-          <a:prstGeom prst="rect">
-            <a:avLst/>
-          </a:prstGeom>
-          <a:solidFill>
-            <a:srgbClr val="BF3A1E"/>
-          </a:solidFill>
-          <a:ln/>
-        </p:spPr>
-      </p:sp>
-      <p:sp>
-        <p:nvSpPr>
-          <p:cNvPr id="19" name="Text 17"/>
-          <p:cNvSpPr txBox="1"/>
-          <p:nvPr/>
-        </p:nvSpPr>
-        <p:spPr>
-          <a:xfrm>
-            <a:off x="7635240" y="1554480"/>
-            <a:ext cx="4114800" cy="548640"/>
-          </a:xfrm>
-          <a:prstGeom prst="rect">
-            <a:avLst/>
-          </a:prstGeom>
-          <a:noFill/>
-          <a:ln/>
-        </p:spPr>
-        <p:txBody>
-          <a:bodyPr wrap="square" lIns="0" tIns="0" rIns="0" bIns="0" rtlCol="0" anchor="ctr"/>
-          <a:lstStyle/>
-          <a:p>
-            <a:pPr indent="0" marL="0">
-              <a:buNone/>
-            </a:pPr>
-            <a:r>
-              <a:rPr lang="en-US" sz="1800" dirty="0">
-                <a:solidFill>
-                  <a:srgbClr val="1A1712"/>
-                </a:solidFill>
-                <a:latin typeface="Georgia" pitchFamily="34" charset="0"/>
-                <a:ea typeface="Georgia" pitchFamily="34" charset="-122"/>
-                <a:cs typeface="Georgia" pitchFamily="34" charset="-120"/>
-              </a:rPr>
-              <a:t>real rooms, real MON moving today</a:t>
-            </a:r>
-            <a:endParaRPr lang="en-US" sz="1800" dirty="0"/>
-          </a:p>
-        </p:txBody>
-      </p:sp>
-      <p:sp>
-        <p:nvSpPr>
-          <p:cNvPr id="20" name="Shape 18"/>
-          <p:cNvSpPr/>
-          <p:nvPr/>
-        </p:nvSpPr>
-        <p:spPr>
-          <a:xfrm>
-            <a:off x="7315200" y="2532888"/>
-            <a:ext cx="146304" cy="146304"/>
-          </a:xfrm>
-          <a:prstGeom prst="rect">
-            <a:avLst/>
-          </a:prstGeom>
-          <a:solidFill>
-            <a:srgbClr val="BF3A1E"/>
-          </a:solidFill>
-          <a:ln/>
-        </p:spPr>
-      </p:sp>
-      <p:sp>
-        <p:nvSpPr>
-          <p:cNvPr id="21" name="Text 19"/>
-          <p:cNvSpPr txBox="1"/>
-          <p:nvPr/>
-        </p:nvSpPr>
-        <p:spPr>
-          <a:xfrm>
-            <a:off x="7635240" y="2423160"/>
-            <a:ext cx="4114800" cy="548640"/>
-          </a:xfrm>
-          <a:prstGeom prst="rect">
-            <a:avLst/>
-          </a:prstGeom>
-          <a:noFill/>
-          <a:ln/>
-        </p:spPr>
-        <p:txBody>
-          <a:bodyPr wrap="square" lIns="0" tIns="0" rIns="0" bIns="0" rtlCol="0" anchor="ctr"/>
-          <a:lstStyle/>
-          <a:p>
-            <a:pPr indent="0" marL="0">
-              <a:buNone/>
-            </a:pPr>
-            <a:r>
-              <a:rPr lang="en-US" sz="1800" dirty="0">
-                <a:solidFill>
-                  <a:srgbClr val="1A1712"/>
-                </a:solidFill>
-                <a:latin typeface="Georgia" pitchFamily="34" charset="0"/>
-                <a:ea typeface="Georgia" pitchFamily="34" charset="-122"/>
-                <a:cs typeface="Georgia" pitchFamily="34" charset="-120"/>
-              </a:rPr>
-              <a:t>latency printed on every message</a:t>
-            </a:r>
-            <a:endParaRPr lang="en-US" sz="1800" dirty="0"/>
-          </a:p>
-        </p:txBody>
-      </p:sp>
-      <p:sp>
-        <p:nvSpPr>
-          <p:cNvPr id="22" name="Shape 20"/>
-          <p:cNvSpPr/>
-          <p:nvPr/>
-        </p:nvSpPr>
-        <p:spPr>
-          <a:xfrm>
-            <a:off x="7315200" y="3401568"/>
-            <a:ext cx="146304" cy="146304"/>
-          </a:xfrm>
-          <a:prstGeom prst="rect">
-            <a:avLst/>
-          </a:prstGeom>
-          <a:solidFill>
-            <a:srgbClr val="BF3A1E"/>
-          </a:solidFill>
-          <a:ln/>
-        </p:spPr>
-      </p:sp>
-      <p:sp>
-        <p:nvSpPr>
-          <p:cNvPr id="23" name="Text 21"/>
-          <p:cNvSpPr txBox="1"/>
-          <p:nvPr/>
-        </p:nvSpPr>
-        <p:spPr>
-          <a:xfrm>
-            <a:off x="7635240" y="3291840"/>
-            <a:ext cx="4114800" cy="548640"/>
-          </a:xfrm>
-          <a:prstGeom prst="rect">
-            <a:avLst/>
-          </a:prstGeom>
-          <a:noFill/>
-          <a:ln/>
-        </p:spPr>
-        <p:txBody>
-          <a:bodyPr wrap="square" lIns="0" tIns="0" rIns="0" bIns="0" rtlCol="0" anchor="ctr"/>
-          <a:lstStyle/>
-          <a:p>
-            <a:pPr indent="0" marL="0">
-              <a:buNone/>
-            </a:pPr>
-            <a:r>
-              <a:rPr lang="en-US" sz="1800" dirty="0">
-                <a:solidFill>
-                  <a:srgbClr val="1A1712"/>
-                </a:solidFill>
-                <a:latin typeface="Georgia" pitchFamily="34" charset="0"/>
-                <a:ea typeface="Georgia" pitchFamily="34" charset="-122"/>
-                <a:cs typeface="Georgia" pitchFamily="34" charset="-120"/>
-              </a:rPr>
-              <a:t>a 67-line contract — verified</a:t>
-            </a:r>
-            <a:endParaRPr lang="en-US" sz="1800" dirty="0"/>
-          </a:p>
-        </p:txBody>
-      </p:sp>
-      <p:sp>
-        <p:nvSpPr>
-          <p:cNvPr id="24" name="Shape 22"/>
-          <p:cNvSpPr/>
-          <p:nvPr/>
-        </p:nvSpPr>
-        <p:spPr>
-          <a:xfrm>
-            <a:off x="7315200" y="4270248"/>
-            <a:ext cx="146304" cy="146304"/>
-          </a:xfrm>
-          <a:prstGeom prst="rect">
-            <a:avLst/>
-          </a:prstGeom>
-          <a:solidFill>
-            <a:srgbClr val="BF3A1E"/>
-          </a:solidFill>
-          <a:ln/>
-        </p:spPr>
-      </p:sp>
-      <p:sp>
-        <p:nvSpPr>
-          <p:cNvPr id="25" name="Text 23"/>
-          <p:cNvSpPr txBox="1"/>
-          <p:nvPr/>
-        </p:nvSpPr>
-        <p:spPr>
-          <a:xfrm>
-            <a:off x="7635240" y="4160520"/>
-            <a:ext cx="4114800" cy="548640"/>
-          </a:xfrm>
-          <a:prstGeom prst="rect">
-            <a:avLst/>
-          </a:prstGeom>
-          <a:noFill/>
-          <a:ln/>
-        </p:spPr>
-        <p:txBody>
-          <a:bodyPr wrap="square" lIns="0" tIns="0" rIns="0" bIns="0" rtlCol="0" anchor="ctr"/>
-          <a:lstStyle/>
-          <a:p>
-            <a:pPr indent="0" marL="0">
-              <a:buNone/>
-            </a:pPr>
-            <a:r>
-              <a:rPr lang="en-US" sz="1800" dirty="0">
-                <a:solidFill>
-                  <a:srgbClr val="1A1712"/>
-                </a:solidFill>
-                <a:latin typeface="Georgia" pitchFamily="34" charset="0"/>
-                <a:ea typeface="Georgia" pitchFamily="34" charset="-122"/>
-                <a:cs typeface="Georgia" pitchFamily="34" charset="-120"/>
-              </a:rPr>
-              <a:t>zero servers: the chain is the backend</a:t>
-            </a:r>
-            <a:endParaRPr lang="en-US" sz="1800" dirty="0"/>
-          </a:p>
-        </p:txBody>
-      </p:sp>
-      <p:sp>
-        <p:nvSpPr>
-          <p:cNvPr id="26" name="Text 24"/>
-          <p:cNvSpPr txBox="1"/>
-          <p:nvPr/>
-        </p:nvSpPr>
-        <p:spPr>
-          <a:xfrm>
-            <a:off x="7315200" y="5029200"/>
-            <a:ext cx="4480560" cy="457200"/>
-          </a:xfrm>
-          <a:prstGeom prst="rect">
-            <a:avLst/>
-          </a:prstGeom>
-          <a:noFill/>
-          <a:ln/>
-        </p:spPr>
-        <p:txBody>
-          <a:bodyPr wrap="square" lIns="0" tIns="0" rIns="0" bIns="0" rtlCol="0" anchor="ctr"/>
-          <a:lstStyle/>
-          <a:p>
-            <a:pPr indent="0" marL="0">
-              <a:buNone/>
-            </a:pPr>
-            <a:r>
-              <a:rPr lang="en-US" sz="1400" b="1" dirty="0">
-                <a:solidFill>
-                  <a:srgbClr val="BF3A1E"/>
-                </a:solidFill>
-                <a:latin typeface="Courier New" pitchFamily="34" charset="0"/>
-                <a:ea typeface="Courier New" pitchFamily="34" charset="-122"/>
-                <a:cs typeface="Courier New" pitchFamily="34" charset="-120"/>
-              </a:rPr>
-              <a:t>try it from your phone right now</a:t>
-            </a:r>
-            <a:endParaRPr lang="en-US" sz="1400" dirty="0"/>
           </a:p>
         </p:txBody>
       </p:sp>
@@ -4515,7 +4032,7 @@
     <p:bg>
       <p:bgPr>
         <a:solidFill>
-          <a:srgbClr val="1A1712"/>
+          <a:srgbClr val="F4EFE6"/>
         </a:solidFill>
       </p:bgPr>
     </p:bg>
@@ -4535,73 +4052,53 @@
       </p:grpSpPr>
       <p:sp>
         <p:nvSpPr>
-          <p:cNvPr id="2" name="Shape 0"/>
-          <p:cNvSpPr/>
-          <p:nvPr/>
-        </p:nvSpPr>
-        <p:spPr>
-          <a:xfrm>
-            <a:off x="566928" y="665683"/>
-            <a:ext cx="241402" cy="241402"/>
-          </a:xfrm>
-          <a:prstGeom prst="rect">
-            <a:avLst/>
-          </a:prstGeom>
-          <a:solidFill>
-            <a:srgbClr val="BF3A1E"/>
-          </a:solidFill>
-          <a:ln/>
-        </p:spPr>
-      </p:sp>
-      <p:sp>
-        <p:nvSpPr>
-          <p:cNvPr id="3" name="Text 1"/>
-          <p:cNvSpPr txBox="1"/>
-          <p:nvPr/>
-        </p:nvSpPr>
-        <p:spPr>
-          <a:xfrm>
-            <a:off x="918058" y="391363"/>
-            <a:ext cx="3657600" cy="526694"/>
-          </a:xfrm>
-          <a:prstGeom prst="rect">
-            <a:avLst/>
-          </a:prstGeom>
-          <a:noFill/>
-          <a:ln/>
-        </p:spPr>
-        <p:txBody>
-          <a:bodyPr wrap="square" lIns="0" tIns="0" rIns="0" bIns="0" rtlCol="0" anchor="ctr"/>
-          <a:lstStyle/>
-          <a:p>
-            <a:pPr indent="0" marL="0">
-              <a:buNone/>
-            </a:pPr>
-            <a:r>
-              <a:rPr lang="en-US" sz="2400" dirty="0">
-                <a:solidFill>
-                  <a:srgbClr val="F4EFE6"/>
+          <p:cNvPr id="2" name="Text 0"/>
+          <p:cNvSpPr txBox="1"/>
+          <p:nvPr/>
+        </p:nvSpPr>
+        <p:spPr>
+          <a:xfrm>
+            <a:off x="640080" y="2103120"/>
+            <a:ext cx="10972800" cy="1188720"/>
+          </a:xfrm>
+          <a:prstGeom prst="rect">
+            <a:avLst/>
+          </a:prstGeom>
+          <a:noFill/>
+          <a:ln/>
+        </p:spPr>
+        <p:txBody>
+          <a:bodyPr wrap="square" lIns="0" tIns="0" rIns="0" bIns="0" rtlCol="0" anchor="ctr"/>
+          <a:lstStyle/>
+          <a:p>
+            <a:pPr algn="ctr" indent="0" marL="0">
+              <a:buNone/>
+            </a:pPr>
+            <a:r>
+              <a:rPr lang="en-US" sz="6400" dirty="0">
+                <a:solidFill>
+                  <a:srgbClr val="1A1712"/>
                 </a:solidFill>
                 <a:latin typeface="Alsina" pitchFamily="34" charset="0"/>
                 <a:ea typeface="Alsina" pitchFamily="34" charset="-122"/>
                 <a:cs typeface="Alsina" pitchFamily="34" charset="-120"/>
               </a:rPr>
-              <a:t>MonadChat</a:t>
-            </a:r>
-            <a:endParaRPr lang="en-US" sz="2400" dirty="0"/>
-          </a:p>
-        </p:txBody>
-      </p:sp>
-      <p:sp>
-        <p:nvSpPr>
-          <p:cNvPr id="4" name="Text 2"/>
-          <p:cNvSpPr txBox="1"/>
-          <p:nvPr/>
-        </p:nvSpPr>
-        <p:spPr>
-          <a:xfrm>
-            <a:off x="548640" y="1920240"/>
-            <a:ext cx="11064240" cy="1188720"/>
+              <a:t>Chat is a revenue stream now.</a:t>
+            </a:r>
+            <a:endParaRPr lang="en-US" sz="6400" dirty="0"/>
+          </a:p>
+        </p:txBody>
+      </p:sp>
+      <p:sp>
+        <p:nvSpPr>
+          <p:cNvPr id="3" name="Text 1"/>
+          <p:cNvSpPr txBox="1"/>
+          <p:nvPr/>
+        </p:nvSpPr>
+        <p:spPr>
+          <a:xfrm>
+            <a:off x="640080" y="3611880"/>
+            <a:ext cx="10972800" cy="640080"/>
           </a:xfrm>
           <a:prstGeom prst="rect">
             <a:avLst/>
@@ -4617,46 +4114,7 @@
               <a:buNone/>
             </a:pPr>
             <a:r>
-              <a:rPr lang="en-US" sz="6400" dirty="0">
-                <a:solidFill>
-                  <a:srgbClr val="F4EFE6"/>
-                </a:solidFill>
-                <a:latin typeface="Alsina" pitchFamily="34" charset="0"/>
-                <a:ea typeface="Alsina" pitchFamily="34" charset="-122"/>
-                <a:cs typeface="Alsina" pitchFamily="34" charset="-120"/>
-              </a:rPr>
-              <a:t>Chat is a revenue stream now.</a:t>
-            </a:r>
-            <a:endParaRPr lang="en-US" sz="6400" dirty="0"/>
-          </a:p>
-        </p:txBody>
-      </p:sp>
-      <p:sp>
-        <p:nvSpPr>
-          <p:cNvPr id="5" name="Text 3"/>
-          <p:cNvSpPr txBox="1"/>
-          <p:nvPr/>
-        </p:nvSpPr>
-        <p:spPr>
-          <a:xfrm>
-            <a:off x="548640" y="3474720"/>
-            <a:ext cx="11064240" cy="640080"/>
-          </a:xfrm>
-          <a:prstGeom prst="rect">
-            <a:avLst/>
-          </a:prstGeom>
-          <a:noFill/>
-          <a:ln/>
-        </p:spPr>
-        <p:txBody>
-          <a:bodyPr wrap="square" lIns="0" tIns="0" rIns="0" bIns="0" rtlCol="0" anchor="ctr"/>
-          <a:lstStyle/>
-          <a:p>
-            <a:pPr algn="ctr" indent="0" marL="0">
-              <a:buNone/>
-            </a:pPr>
-            <a:r>
-              <a:rPr lang="en-US" sz="3000" b="1" dirty="0">
+              <a:rPr lang="en-US" sz="2800" b="1" dirty="0">
                 <a:solidFill>
                   <a:srgbClr val="BF3A1E"/>
                 </a:solidFill>
@@ -4666,20 +4124,20 @@
               </a:rPr>
               <a:t>monadchat-rvfc1.vercel.app</a:t>
             </a:r>
-            <a:endParaRPr lang="en-US" sz="3000" dirty="0"/>
-          </a:p>
-        </p:txBody>
-      </p:sp>
-      <p:sp>
-        <p:nvSpPr>
-          <p:cNvPr id="6" name="Text 4"/>
-          <p:cNvSpPr txBox="1"/>
-          <p:nvPr/>
-        </p:nvSpPr>
-        <p:spPr>
-          <a:xfrm>
-            <a:off x="548640" y="4251960"/>
-            <a:ext cx="11064240" cy="457200"/>
+            <a:endParaRPr lang="en-US" sz="2800" dirty="0"/>
+          </a:p>
+        </p:txBody>
+      </p:sp>
+      <p:sp>
+        <p:nvSpPr>
+          <p:cNvPr id="4" name="Text 2"/>
+          <p:cNvSpPr txBox="1"/>
+          <p:nvPr/>
+        </p:nvSpPr>
+        <p:spPr>
+          <a:xfrm>
+            <a:off x="640080" y="4389120"/>
+            <a:ext cx="10972800" cy="457200"/>
           </a:xfrm>
           <a:prstGeom prst="rect">
             <a:avLst/>
@@ -4695,9 +4153,9 @@
               <a:buNone/>
             </a:pPr>
             <a:r>
-              <a:rPr lang="en-US" sz="1800" i="1" dirty="0">
-                <a:solidFill>
-                  <a:srgbClr val="BFB6A4"/>
+              <a:rPr lang="en-US" sz="1700" i="1" dirty="0">
+                <a:solidFill>
+                  <a:srgbClr val="8A8274"/>
                 </a:solidFill>
                 <a:latin typeface="Georgia" pitchFamily="34" charset="0"/>
                 <a:ea typeface="Georgia" pitchFamily="34" charset="-122"/>
@@ -4705,42 +4163,19 @@
               </a:rPr>
               <a:t>open the demo · write a word · watch it land in half a second</a:t>
             </a:r>
-            <a:endParaRPr lang="en-US" sz="1800" dirty="0"/>
-          </a:p>
-        </p:txBody>
-      </p:sp>
-      <p:sp>
-        <p:nvSpPr>
-          <p:cNvPr id="7" name="Shape 5"/>
-          <p:cNvSpPr/>
-          <p:nvPr/>
-        </p:nvSpPr>
-        <p:spPr>
-          <a:xfrm>
-            <a:off x="548640" y="5806440"/>
-            <a:ext cx="11091672" cy="0"/>
-          </a:xfrm>
-          <a:prstGeom prst="line">
-            <a:avLst/>
-          </a:prstGeom>
-          <a:noFill/>
-          <a:ln w="12700">
-            <a:solidFill>
-              <a:srgbClr val="4A443A"/>
-            </a:solidFill>
-            <a:prstDash val="solid"/>
-          </a:ln>
-        </p:spPr>
-      </p:sp>
-      <p:sp>
-        <p:nvSpPr>
-          <p:cNvPr id="8" name="Text 6"/>
-          <p:cNvSpPr txBox="1"/>
-          <p:nvPr/>
-        </p:nvSpPr>
-        <p:spPr>
-          <a:xfrm>
-            <a:off x="548640" y="5943600"/>
+            <a:endParaRPr lang="en-US" sz="1700" dirty="0"/>
+          </a:p>
+        </p:txBody>
+      </p:sp>
+      <p:sp>
+        <p:nvSpPr>
+          <p:cNvPr id="5" name="Text 3"/>
+          <p:cNvSpPr txBox="1"/>
+          <p:nvPr/>
+        </p:nvSpPr>
+        <p:spPr>
+          <a:xfrm>
+            <a:off x="640080" y="6035040"/>
             <a:ext cx="5943600" cy="365760"/>
           </a:xfrm>
           <a:prstGeom prst="rect">
@@ -4757,9 +4192,9 @@
               <a:buNone/>
             </a:pPr>
             <a:r>
-              <a:rPr lang="en-US" sz="1200" dirty="0">
-                <a:solidFill>
-                  <a:srgbClr val="BFB6A4"/>
+              <a:rPr lang="en-US" sz="1100" dirty="0">
+                <a:solidFill>
+                  <a:srgbClr val="8A8274"/>
                 </a:solidFill>
                 <a:latin typeface="Courier New" pitchFamily="34" charset="0"/>
                 <a:ea typeface="Courier New" pitchFamily="34" charset="-122"/>
@@ -4767,19 +4202,19 @@
               </a:rPr>
               <a:t>contract 0xba3c36b0…4be8 — verified</a:t>
             </a:r>
-            <a:endParaRPr lang="en-US" sz="1200" dirty="0"/>
-          </a:p>
-        </p:txBody>
-      </p:sp>
-      <p:sp>
-        <p:nvSpPr>
-          <p:cNvPr id="9" name="Text 7"/>
-          <p:cNvSpPr txBox="1"/>
-          <p:nvPr/>
-        </p:nvSpPr>
-        <p:spPr>
-          <a:xfrm>
-            <a:off x="6583680" y="5943600"/>
+            <a:endParaRPr lang="en-US" sz="1100" dirty="0"/>
+          </a:p>
+        </p:txBody>
+      </p:sp>
+      <p:sp>
+        <p:nvSpPr>
+          <p:cNvPr id="6" name="Text 4"/>
+          <p:cNvSpPr txBox="1"/>
+          <p:nvPr/>
+        </p:nvSpPr>
+        <p:spPr>
+          <a:xfrm>
+            <a:off x="6492240" y="6035040"/>
             <a:ext cx="5029200" cy="365760"/>
           </a:xfrm>
           <a:prstGeom prst="rect">
@@ -4796,9 +4231,9 @@
               <a:buNone/>
             </a:pPr>
             <a:r>
-              <a:rPr lang="en-US" sz="1200" spc="200" kern="0" dirty="0">
-                <a:solidFill>
-                  <a:srgbClr val="BFB6A4"/>
+              <a:rPr lang="en-US" sz="1100" spc="200" kern="0" dirty="0">
+                <a:solidFill>
+                  <a:srgbClr val="8A8274"/>
                 </a:solidFill>
                 <a:latin typeface="Courier New" pitchFamily="34" charset="0"/>
                 <a:ea typeface="Courier New" pitchFamily="34" charset="-122"/>
@@ -4806,7 +4241,7 @@
               </a:rPr>
               <a:t>MONAD BLITZ · AMSTERDAM · 2026</a:t>
             </a:r>
-            <a:endParaRPr lang="en-US" sz="1200" dirty="0"/>
+            <a:endParaRPr lang="en-US" sz="1100" dirty="0"/>
           </a:p>
         </p:txBody>
       </p:sp>

</xml_diff>